<commit_message>
Revise Day 5 observability module
Replace the original tracing walkthrough with grounded client-side and server-side trace demos, synchronize the deck and runbook, and update workshop references and timing.

Co-authored-by: Copilot App <223556219+Copilot@users.noreply.github.com>
</commit_message>
<xml_diff>
--- a/decks/day5/module-1-observability-tracing.pptx
+++ b/decks/day5/module-1-observability-tracing.pptx
@@ -6,9 +6,11 @@
   </p:sldMasterIdLst>
   <p:sldIdLst>
     <p:sldId id="256" r:id="rId2"/>
+    <p:sldId id="265" r:id="rId16"/>
     <p:sldId id="257" r:id="rId3"/>
     <p:sldId id="258" r:id="rId4"/>
     <p:sldId id="259" r:id="rId5"/>
+    <p:sldId id="266" r:id="rId17"/>
     <p:sldId id="260" r:id="rId6"/>
     <p:sldId id="261" r:id="rId7"/>
     <p:sldId id="262" r:id="rId8"/>
@@ -510,9 +512,11 @@
           <a:p>
             <a:r>
               <a:rPr lang="en-US" dirty="0"/>
-              <a:t>• Allow 1 minute. Reintroduce the presenter-prepared technical-documentation assistant: Planner scopes the request, Retriever gathers evidence, and Critic either requests one bounded revision or stops. No prior lab completion is assumed. The module asks what evidence lets an operator explain one run without mistaking operational health for answer quality.
+              <a:t>• Allow 1 minute. Introduce the two prepared paths used later in the demo. The official Agent Framework WeatherAgent sample creates client-side automatic spans for agent, model, and tool operations and adds one custom parent span around the chat session. The presenter-controlled Prompt agent demonstrates the server-side trace Foundry records after Application Insights is connected. No prior lab completion, attendee-owned agent, or attendee-owned Azure resource is assumed. The module asks what evidence lets an operator explain one run without mistaking operational health for answer quality.
 • GROUNDING SOURCE: https://learn.microsoft.com/azure/foundry/concepts/observability
-• GROUNDING SOURCE: https://learn.microsoft.com/azure/foundry/observability/concepts/trace-agent-concept</a:t>
+• GROUNDING SOURCE: https://learn.microsoft.com/azure/foundry/observability/concepts/trace-agent-concept
+• GROUNDING SOURCE: https://learn.microsoft.com/agent-framework/agents/observability?pivots=programming-language-python
+• GROUNDING SOURCE: https://learn.microsoft.com/azure/foundry/observability/how-to/trace-agent-setup</a:t>
             </a:r>
             <a:endParaRPr lang="en-US" dirty="0"/>
           </a:p>
@@ -545,6 +549,184 @@
     <p:extLst>
       <p:ext uri="{BB962C8B-B14F-4D97-AF65-F5344CB8AC3E}">
         <p14:creationId xmlns:p14="http://schemas.microsoft.com/office/powerpoint/2010/main" val="1024086991"/>
+      </p:ext>
+    </p:extLst>
+  </p:cSld>
+  <p:clrMapOvr>
+    <a:masterClrMapping/>
+  </p:clrMapOvr>
+</p:notes>
+</file>
+
+<file path=ppt/notesSlides/notesSlide10.xml><?xml version="1.0" encoding="utf-8"?>
+<p:notes xmlns:a="http://schemas.openxmlformats.org/drawingml/2006/main" xmlns:r="http://schemas.openxmlformats.org/officeDocument/2006/relationships" xmlns:p="http://schemas.openxmlformats.org/presentationml/2006/main">
+  <p:cSld>
+    <p:spTree>
+      <p:nvGrpSpPr>
+        <p:cNvPr id="1" name=""/>
+        <p:cNvGrpSpPr/>
+        <p:nvPr/>
+      </p:nvGrpSpPr>
+      <p:grpSpPr>
+        <a:xfrm>
+          <a:off x="0" y="0"/>
+          <a:ext cx="0" cy="0"/>
+          <a:chOff x="0" y="0"/>
+          <a:chExt cx="0" cy="0"/>
+        </a:xfrm>
+      </p:grpSpPr>
+      <p:sp>
+        <p:nvSpPr>
+          <p:cNvPr id="2" name="Slide Image Placeholder 1"/>
+          <p:cNvSpPr>
+            <a:spLocks noGrp="1" noRot="1" noChangeAspect="1"/>
+          </p:cNvSpPr>
+          <p:nvPr>
+            <p:ph type="sldImg"/>
+          </p:nvPr>
+        </p:nvSpPr>
+        <p:spPr/>
+      </p:sp>
+      <p:sp>
+        <p:nvSpPr>
+          <p:cNvPr id="3" name="Notes Placeholder 2"/>
+          <p:cNvSpPr>
+            <a:spLocks noGrp="1"/>
+          </p:cNvSpPr>
+          <p:nvPr>
+            <p:ph type="body" idx="1"/>
+          </p:nvPr>
+        </p:nvSpPr>
+        <p:spPr/>
+        <p:txBody>
+          <a:bodyPr/>
+          <a:lstStyle/>
+          <a:p>
+            <a:r>
+              <a:rPr lang="en-US" dirty="0"/>
+              <a:t>• Allow about 3 minutes within the existing opening discussion. Complex agent behavior can be difficult to debug because a response can involve many input-dependent and nested operations, each with substantial inputs and outputs. Tracing places the recorded primitives for one run in invocation order and exposes their recorded inputs and outputs for inspection. Emphasize "recorded": a trace shows instrumented and exported operations, not unrecorded work or private model reasoning. Foundry tracing is generally available for prompt and hosted agents; workflow and external-agent tracing are preview.
+• GROUNDING SOURCE: https://learn.microsoft.com/en-us/azure/foundry/observability/concepts/trace-agent-concept</a:t>
+            </a:r>
+            <a:endParaRPr lang="en-US" dirty="0"/>
+          </a:p>
+        </p:txBody>
+      </p:sp>
+      <p:sp>
+        <p:nvSpPr>
+          <p:cNvPr id="4" name="Slide Number Placeholder 3"/>
+          <p:cNvSpPr>
+            <a:spLocks noGrp="1"/>
+          </p:cNvSpPr>
+          <p:nvPr>
+            <p:ph type="sldNum" sz="quarter" idx="10"/>
+          </p:nvPr>
+        </p:nvSpPr>
+        <p:spPr/>
+        <p:txBody>
+          <a:bodyPr/>
+          <a:lstStyle/>
+          <a:p>
+            <a:fld id="{B33434C4-5F3D-4F86-8A13-78E4FA2D3AD2}" type="slidenum">
+              <a:rPr lang="en-US"/>
+              <a:t>2</a:t>
+            </a:fld>
+            <a:endParaRPr lang="en-US"/>
+          </a:p>
+        </p:txBody>
+      </p:sp>
+    </p:spTree>
+    <p:extLst>
+      <p:ext uri="{BB962C8B-B14F-4D97-AF65-F5344CB8AC3E}">
+        <p14:creationId xmlns:p14="http://schemas.microsoft.com/office/powerpoint/2010/main" val="1435487042"/>
+      </p:ext>
+    </p:extLst>
+  </p:cSld>
+  <p:clrMapOvr>
+    <a:masterClrMapping/>
+  </p:clrMapOvr>
+</p:notes>
+</file>
+
+<file path=ppt/notesSlides/notesSlide11.xml><?xml version="1.0" encoding="utf-8"?>
+<p:notes xmlns:a="http://schemas.openxmlformats.org/drawingml/2006/main" xmlns:r="http://schemas.openxmlformats.org/officeDocument/2006/relationships" xmlns:p="http://schemas.openxmlformats.org/presentationml/2006/main">
+  <p:cSld>
+    <p:spTree>
+      <p:nvGrpSpPr>
+        <p:cNvPr id="1" name=""/>
+        <p:cNvGrpSpPr/>
+        <p:nvPr/>
+      </p:nvGrpSpPr>
+      <p:grpSpPr>
+        <a:xfrm>
+          <a:off x="0" y="0"/>
+          <a:ext cx="0" cy="0"/>
+          <a:chOff x="0" y="0"/>
+          <a:chExt cx="0" cy="0"/>
+        </a:xfrm>
+      </p:grpSpPr>
+      <p:sp>
+        <p:nvSpPr>
+          <p:cNvPr id="2" name="Slide Image Placeholder 1"/>
+          <p:cNvSpPr>
+            <a:spLocks noGrp="1" noRot="1" noChangeAspect="1"/>
+          </p:cNvSpPr>
+          <p:nvPr>
+            <p:ph type="sldImg"/>
+          </p:nvPr>
+        </p:nvSpPr>
+        <p:spPr/>
+      </p:sp>
+      <p:sp>
+        <p:nvSpPr>
+          <p:cNvPr id="3" name="Notes Placeholder 2"/>
+          <p:cNvSpPr>
+            <a:spLocks noGrp="1"/>
+          </p:cNvSpPr>
+          <p:nvPr>
+            <p:ph type="body" idx="1"/>
+          </p:nvPr>
+        </p:nvSpPr>
+        <p:spPr/>
+        <p:txBody>
+          <a:bodyPr/>
+          <a:lstStyle/>
+          <a:p>
+            <a:r>
+              <a:rPr lang="en-US" dirty="0"/>
+              <a:t>• Use this as the second half of the existing instrumentation discussion rather than adding time to the 30-minute module. Microsoft recommends starting with server-side tracing: after Application Insights is connected to the Foundry project, Foundry records supported hosted-agent and workflow activity without application code changes. Add client-side instrumentation when the team also needs visibility into application-owned logic surrounding an agent call. The Microsoft Foundry SDK and OpenTelemetry tracing packages provide that instrumentation, which must be configured and exported. Treat the two trace sources as complementary, and never imply that either source exposes uninstrumented work. Tracing is generally available for prompt and hosted agents; workflow and external-agent tracing are preview.
+• GROUNDING SOURCE: https://learn.microsoft.com/en-us/azure/foundry/observability/how-to/trace-agent-setup?tabs=python#instrument-ai-agents</a:t>
+            </a:r>
+            <a:endParaRPr lang="en-US" dirty="0"/>
+          </a:p>
+        </p:txBody>
+      </p:sp>
+      <p:sp>
+        <p:nvSpPr>
+          <p:cNvPr id="4" name="Slide Number Placeholder 3"/>
+          <p:cNvSpPr>
+            <a:spLocks noGrp="1"/>
+          </p:cNvSpPr>
+          <p:nvPr>
+            <p:ph type="sldNum" sz="quarter" idx="10"/>
+          </p:nvPr>
+        </p:nvSpPr>
+        <p:spPr/>
+        <p:txBody>
+          <a:bodyPr/>
+          <a:lstStyle/>
+          <a:p>
+            <a:fld id="{6D3EA55B-BF00-42D0-BAD3-3C0758F5364B}" type="slidenum">
+              <a:rPr lang="en-US"/>
+              <a:t>6</a:t>
+            </a:fld>
+            <a:endParaRPr lang="en-US"/>
+          </a:p>
+        </p:txBody>
+      </p:sp>
+    </p:spTree>
+    <p:extLst>
+      <p:ext uri="{BB962C8B-B14F-4D97-AF65-F5344CB8AC3E}">
+        <p14:creationId xmlns:p14="http://schemas.microsoft.com/office/powerpoint/2010/main" val="927504188"/>
       </p:ext>
     </p:extLst>
   </p:cSld>
@@ -600,7 +782,7 @@
           <a:p>
             <a:r>
               <a:rPr lang="en-US" dirty="0"/>
-              <a:t>• Allow 4 minutes. Observability is the umbrella ability to understand and troubleshoot behavior. Monitoring watches operational and quality signals over time; evaluation judges an output or action against explicit criteria. Stress that a request can have no exception and still produce a poor answer, while a good answer can still be too slow or costly.
+              <a:t>• Allow 2 minutes. Observability is the umbrella ability to understand and troubleshoot behavior. Monitoring watches operational and quality signals over time; evaluation judges an output or action against explicit criteria. Stress that a request can have no exception and still produce a poor answer, while a good answer can still be too slow or costly.
 • GROUNDING SOURCE: https://learn.microsoft.com/azure/foundry/concepts/observability</a:t>
             </a:r>
             <a:endParaRPr lang="en-US" dirty="0"/>
@@ -624,7 +806,7 @@
           <a:p>
             <a:fld id="{F7021451-1387-4CA6-816F-3879F97B5CBC}" type="slidenum">
               <a:rPr lang="en-US"/>
-              <a:t>2</a:t>
+              <a:t>3</a:t>
             </a:fld>
             <a:endParaRPr lang="en-US"/>
           </a:p>
@@ -689,8 +871,9 @@
           <a:p>
             <a:r>
               <a:rPr lang="en-US" dirty="0"/>
-              <a:t>• Allow 4 minutes. Point to the supplied reference run while defining the terms. A trace is the journey of one execution; a span is one timed operation within it; attributes are key-value context on that operation. The console event list can be useful evidence, but without trace context, instrumentation, and export it is not automatically a distributed trace.
-• GROUNDING SOURCE: https://learn.microsoft.com/azure/foundry/observability/concepts/trace-agent-concept</a:t>
+              <a:t>• Allow 2 minutes. Point to the WeatherAgent sample while defining the terms. A trace is one correlated execution journey; a span is one timed operation within it; attributes are key-value context on that operation. Agent Framework emits automatic spans for agent invocation, model chat, and function-tool execution. Application code can add custom spans with get_tracer().start_as_current_span(). Because the custom span is current while the agent runs, the automatic spans join the same trace beneath it.
+• GROUNDING SOURCE: https://learn.microsoft.com/azure/foundry/observability/concepts/trace-agent-concept
+• GROUNDING SOURCE: https://learn.microsoft.com/agent-framework/agents/observability?pivots=programming-language-python</a:t>
             </a:r>
             <a:endParaRPr lang="en-US" dirty="0"/>
           </a:p>
@@ -713,7 +896,7 @@
           <a:p>
             <a:fld id="{F7021451-1387-4CA6-816F-3879F97B5CBC}" type="slidenum">
               <a:rPr lang="en-US"/>
-              <a:t>3</a:t>
+              <a:t>4</a:t>
             </a:fld>
             <a:endParaRPr lang="en-US"/>
           </a:p>
@@ -805,7 +988,7 @@
           <a:p>
             <a:fld id="{F7021451-1387-4CA6-816F-3879F97B5CBC}" type="slidenum">
               <a:rPr lang="en-US"/>
-              <a:t>4</a:t>
+              <a:t>5</a:t>
             </a:fld>
             <a:endParaRPr lang="en-US"/>
           </a:p>
@@ -870,7 +1053,7 @@
           <a:p>
             <a:r>
               <a:rPr lang="en-US" dirty="0"/>
-              <a:t>• Allow 3 minutes. In MAF workflows, a message-send span can be a child of the sending executor, while the receiving executor is linked to that send because the work is causally related but not nested. A conversation persists dialogue across turns; a response records processing output; neither identifier should be substituted for a trace ID. Streaming exposes partial output before completion, but the documentation does not promise one span per token.
+              <a:t>• Allow 2 minutes. In MAF workflows, a message-send span can be a child of the sending executor, while the receiving executor is linked to that send because the work is causally related but not nested. A conversation persists dialogue across turns; a response records processing output; neither identifier should be substituted for a trace ID. Streaming exposes partial output before completion, but the documentation does not promise one span per token.
 • GROUNDING SOURCE: https://learn.microsoft.com/agent-framework/workflows/observability
 • GROUNDING SOURCE: https://learn.microsoft.com/azure/foundry/agents/concepts/runtime-components
 • GROUNDING SOURCE: https://learn.microsoft.com/azure/foundry/observability/concepts/trace-agent-concept</a:t>
@@ -896,7 +1079,7 @@
           <a:p>
             <a:fld id="{F7021451-1387-4CA6-816F-3879F97B5CBC}" type="slidenum">
               <a:rPr lang="en-US"/>
-              <a:t>5</a:t>
+              <a:t>7</a:t>
             </a:fld>
             <a:endParaRPr lang="en-US"/>
           </a:p>
@@ -961,10 +1144,11 @@
           <a:p>
             <a:r>
               <a:rPr lang="en-US" dirty="0"/>
-              <a:t>• Allow 6 minutes. Use the runbook's read-only, presenter-prepared evidence from one synthetic Planner/Retriever/Critic request. Compare its console events with its authentic exported trace, follow the retrieval and Critic decision, identify the longest recorded operation, and finish by asking what separate evidence establishes answer quality. Never improvise missing spans or identifiers.
-• GROUNDING SOURCE: https://learn.microsoft.com/azure/foundry/observability/concepts/trace-agent-concept
-• GROUNDING SOURCE: https://learn.microsoft.com/agent-framework/workflows/observability
-• GROUNDING SOURCE: https://learn.microsoft.com/azure/foundry/observability/how-to/trace-agent-setup</a:t>
+              <a:t>• Allow 8 minutes. Follow demos/day5/module-1-demo-1-standard-custom-traces.md. Step 1: run the provided copy of Microsoft's WeatherAgent sample and use its printed trace ID to compare the custom Weather Agent Chat parent with the automatic invoke_agent, chat, and any execute_tool spans that were actually emitted. Step 2: run a synthetic prompt against the prepared docs-assistant Prompt agent in the Foundry playground, then open Agents &gt; Traces and inspect the matching server-side trace. If ingestion is delayed, switch to the labeled capture from the rehearsed Prompt-agent run. Compare the recorded boundaries: Foundry records the hosted Prompt-agent path without client-side tracing code, while the WeatherAgent path adds application-owned context. Keep the two trace IDs separate, use synthetic prompts, and do not improvise missing spans or identifiers.
+• GROUNDING SOURCE: https://github.com/microsoft/agent-framework/blob/main/python/samples/02-agents/observability/foundry_tracing.py
+• GROUNDING SOURCE: https://learn.microsoft.com/agent-framework/agents/observability?pivots=programming-language-python
+• GROUNDING SOURCE: https://learn.microsoft.com/azure/foundry/observability/how-to/trace-agent-setup
+• GROUNDING SOURCE: https://learn.microsoft.com/azure/foundry/agents/quickstarts/prompt-agent</a:t>
             </a:r>
             <a:endParaRPr lang="en-US" dirty="0"/>
           </a:p>
@@ -987,7 +1171,7 @@
           <a:p>
             <a:fld id="{F7021451-1387-4CA6-816F-3879F97B5CBC}" type="slidenum">
               <a:rPr lang="en-US"/>
-              <a:t>6</a:t>
+              <a:t>8</a:t>
             </a:fld>
             <a:endParaRPr lang="en-US"/>
           </a:p>
@@ -1079,7 +1263,7 @@
           <a:p>
             <a:fld id="{F7021451-1387-4CA6-816F-3879F97B5CBC}" type="slidenum">
               <a:rPr lang="en-US"/>
-              <a:t>7</a:t>
+              <a:t>9</a:t>
             </a:fld>
             <a:endParaRPr lang="en-US"/>
           </a:p>
@@ -1144,7 +1328,7 @@
           <a:p>
             <a:r>
               <a:rPr lang="en-US" dirty="0"/>
-              <a:t>• Allow 3 minutes. Use only the values actually visible in the prepared evidence. Ask where the delay occurred: the answer is the longest relevant span and its child or linked operations. Ask whether the final answer was good: the trace alone cannot establish that; use an appropriate evaluator or reviewed answer. Also remind the room that traces expose recorded operations, not guaranteed access to a model's private reasoning.
+              <a:t>• Allow 3 minutes. Use only the values actually visible in the WeatherAgent trace. Ask where the delay occurred: the answer comes from the relevant automatic or custom span durations and their relationships, not from an assumed tool or model bottleneck. Ask whether the final answer was good: the trace alone cannot establish that; use an appropriate evaluator or reviewed answer. Also remind the room that traces expose recorded operations, not guaranteed access to a model's private reasoning.
 • GROUNDING SOURCE: https://learn.microsoft.com/azure/foundry/observability/concepts/trace-agent-concept
 • GROUNDING SOURCE: https://learn.microsoft.com/azure/foundry/concepts/observability</a:t>
             </a:r>
@@ -1169,7 +1353,7 @@
           <a:p>
             <a:fld id="{F7021451-1387-4CA6-816F-3879F97B5CBC}" type="slidenum">
               <a:rPr lang="en-US"/>
-              <a:t>8</a:t>
+              <a:t>10</a:t>
             </a:fld>
             <a:endParaRPr lang="en-US"/>
           </a:p>
@@ -1237,6 +1421,7 @@
               <a:t>• Allow 2 minutes. Ask for the four-part operational story: instrument, propagate context, export, inspect. Then ask which evidence answers latency versus quality. Close by handing off to Module 2: the telemetry contract stays the same, but the next question is which VS Code surface should an architect use during development.
 • GROUNDING SOURCE: https://learn.microsoft.com/azure/foundry/concepts/observability
 • GROUNDING SOURCE: https://learn.microsoft.com/azure/foundry/observability/concepts/trace-agent-concept
+• GROUNDING SOURCE: https://learn.microsoft.com/agent-framework/agents/observability?pivots=programming-language-python
 • GROUNDING SOURCE: https://learn.microsoft.com/agent-framework/workflows/observability</a:t>
             </a:r>
             <a:endParaRPr lang="en-US" dirty="0"/>
@@ -1260,7 +1445,7 @@
           <a:p>
             <a:fld id="{F7021451-1387-4CA6-816F-3879F97B5CBC}" type="slidenum">
               <a:rPr lang="en-US"/>
-              <a:t>9</a:t>
+              <a:t>11</a:t>
             </a:fld>
             <a:endParaRPr lang="en-US"/>
           </a:p>
@@ -1936,8 +2121,8 @@
         </p:nvSpPr>
         <p:spPr>
           <a:xfrm>
-            <a:off x="713232" y="1298448"/>
-            <a:ext cx="7150608" cy="1143000"/>
+            <a:off x="713232" y="1097280"/>
+            <a:ext cx="7150608" cy="1371600"/>
           </a:xfrm>
           <a:prstGeom prst="rect">
             <a:avLst/>
@@ -1955,7 +2140,7 @@
               <a:buNone/>
             </a:pPr>
             <a:r>
-              <a:rPr lang="en-US" sz="4700" b="1" dirty="0">
+              <a:rPr lang="en-US" sz="4500" b="1" dirty="0">
                 <a:solidFill>
                   <a:srgbClr val="FFFFFF"/>
                 </a:solidFill>
@@ -1963,9 +2148,21 @@
                 <a:ea typeface="Aptos Display" pitchFamily="34" charset="-122"/>
                 <a:cs typeface="Aptos Display" pitchFamily="34" charset="-120"/>
               </a:rPr>
-              <a:t>Observability and Tracing</a:t>
-            </a:r>
-            <a:endParaRPr lang="en-US" sz="4700" dirty="0"/>
+              <a:t>Observability</a:t>
+            </a:r>
+            <a:br/>
+            <a:r>
+              <a:rPr lang="en-US" sz="4500" b="1" dirty="0">
+                <a:solidFill>
+                  <a:srgbClr val="FFFFFF"/>
+                </a:solidFill>
+                <a:latin typeface="Aptos Display" pitchFamily="34" charset="0"/>
+                <a:ea typeface="Aptos Display" pitchFamily="34" charset="-122"/>
+                <a:cs typeface="Aptos Display" pitchFamily="34" charset="-120"/>
+              </a:rPr>
+              <a:t>in Generative AI</a:t>
+            </a:r>
+            <a:endParaRPr lang="en-US" sz="4500" dirty="0"/>
           </a:p>
         </p:txBody>
       </p:sp>
@@ -2004,7 +2201,7 @@
                 <a:ea typeface="Aptos" pitchFamily="34" charset="-122"/>
                 <a:cs typeface="Aptos" pitchFamily="34" charset="-120"/>
               </a:rPr>
-              <a:t>Follow one request, explain the delay,</a:t>
+              <a:t>Compare client-side and server-side traces,</a:t>
             </a:r>
             <a:endParaRPr lang="en-US" sz="1830" dirty="0"/>
           </a:p>
@@ -2021,7 +2218,7 @@
                 <a:ea typeface="Aptos" pitchFamily="34" charset="-122"/>
                 <a:cs typeface="Aptos" pitchFamily="34" charset="-120"/>
               </a:rPr>
-              <a:t>and protect what telemetry records</a:t>
+              <a:t>explain latency, and govern telemetry</a:t>
             </a:r>
             <a:endParaRPr lang="en-US" sz="1830" dirty="0"/>
           </a:p>
@@ -2104,7 +2301,7 @@
                 <a:ea typeface="Aptos" pitchFamily="34" charset="-122"/>
                 <a:cs typeface="Aptos" pitchFamily="34" charset="-120"/>
               </a:rPr>
-              <a:t>Follow one presenter-prepared request from workflow entry to answer — then ask what the trace still cannot prove.</a:t>
+              <a:t>Compare a client-instrumented trace with a Foundry-managed server-side trace — then ask what neither can prove.</a:t>
             </a:r>
             <a:endParaRPr lang="en-US" sz="1700" dirty="0"/>
           </a:p>
@@ -2223,7 +2420,7 @@
                 <a:ea typeface="Aptos" pitchFamily="34" charset="-122"/>
                 <a:cs typeface="Aptos" pitchFamily="34" charset="-120"/>
               </a:rPr>
-              <a:t>REFERENCE  learn.microsoft.com/azure/foundry/concepts/observability  ·  +1 more in notes</a:t>
+              <a:t>REFERENCE  learn.microsoft.com/azure/foundry/concepts/observability  ·  +3 more in notes</a:t>
             </a:r>
             <a:endParaRPr lang="en-US" sz="940" dirty="0"/>
           </a:p>
@@ -2232,6 +2429,2684 @@
       <p:sp>
         <p:nvSpPr>
           <p:cNvPr id="23" name="Shape 21"/>
+          <p:cNvSpPr/>
+          <p:nvPr/>
+        </p:nvSpPr>
+        <p:spPr>
+          <a:xfrm>
+            <a:off x="0" y="6793992"/>
+            <a:ext cx="12191695" cy="64008"/>
+          </a:xfrm>
+          <a:prstGeom prst="rect">
+            <a:avLst/>
+          </a:prstGeom>
+          <a:solidFill>
+            <a:srgbClr val="16C7E8"/>
+          </a:solidFill>
+          <a:ln/>
+        </p:spPr>
+      </p:sp>
+    </p:spTree>
+  </p:cSld>
+  <p:clrMapOvr>
+    <a:masterClrMapping/>
+  </p:clrMapOvr>
+</p:sld>
+</file>
+
+<file path=ppt/slides/slide10.xml><?xml version="1.0" encoding="utf-8"?>
+<p:sld xmlns:a="http://schemas.openxmlformats.org/drawingml/2006/main" xmlns:r="http://schemas.openxmlformats.org/officeDocument/2006/relationships" xmlns:p="http://schemas.openxmlformats.org/presentationml/2006/main">
+  <p:cSld name="Slide 4">
+    <p:bg>
+      <p:bgPr>
+        <a:solidFill>
+          <a:srgbClr val="F3FAFD"/>
+        </a:solidFill>
+      </p:bgPr>
+    </p:bg>
+    <p:spTree>
+      <p:nvGrpSpPr>
+        <p:cNvPr id="1" name=""/>
+        <p:cNvGrpSpPr/>
+        <p:nvPr/>
+      </p:nvGrpSpPr>
+      <p:grpSpPr>
+        <a:xfrm>
+          <a:off x="0" y="0"/>
+          <a:ext cx="0" cy="0"/>
+          <a:chOff x="0" y="0"/>
+          <a:chExt cx="0" cy="0"/>
+        </a:xfrm>
+      </p:grpSpPr>
+      <p:sp>
+        <p:nvSpPr>
+          <p:cNvPr id="2" name="Shape 0"/>
+          <p:cNvSpPr/>
+          <p:nvPr/>
+        </p:nvSpPr>
+        <p:spPr>
+          <a:xfrm>
+            <a:off x="621792" y="438912"/>
+            <a:ext cx="2176272" cy="310896"/>
+          </a:xfrm>
+          <a:prstGeom prst="roundRect">
+            <a:avLst>
+              <a:gd name="adj" fmla="val 23529"/>
+            </a:avLst>
+          </a:prstGeom>
+          <a:solidFill>
+            <a:srgbClr val="11162B"/>
+          </a:solidFill>
+          <a:ln/>
+        </p:spPr>
+      </p:sp>
+      <p:sp>
+        <p:nvSpPr>
+          <p:cNvPr id="3" name="Text 1"/>
+          <p:cNvSpPr/>
+          <p:nvPr/>
+        </p:nvSpPr>
+        <p:spPr>
+          <a:xfrm>
+            <a:off x="768096" y="530352"/>
+            <a:ext cx="1874520" cy="109728"/>
+          </a:xfrm>
+          <a:prstGeom prst="rect">
+            <a:avLst/>
+          </a:prstGeom>
+          <a:noFill/>
+          <a:ln/>
+        </p:spPr>
+        <p:txBody>
+          <a:bodyPr wrap="square" lIns="0" tIns="0" rIns="0" bIns="0" rtlCol="0" anchor="ctr">
+            <a:normAutofit/>
+          </a:bodyPr>
+          <a:lstStyle/>
+          <a:p>
+            <a:pPr indent="0" marL="0">
+              <a:buNone/>
+            </a:pPr>
+            <a:r>
+              <a:rPr lang="en-US" sz="820" b="1" spc="120" kern="0" dirty="0">
+                <a:solidFill>
+                  <a:srgbClr val="FFFFFF"/>
+                </a:solidFill>
+                <a:latin typeface="Aptos" pitchFamily="34" charset="0"/>
+                <a:ea typeface="Aptos" pitchFamily="34" charset="-122"/>
+                <a:cs typeface="Aptos" pitchFamily="34" charset="-120"/>
+              </a:rPr>
+              <a:t>DAY 5  /  MODULE 1  /  SIGNAL PATH</a:t>
+            </a:r>
+            <a:endParaRPr lang="en-US" sz="820" dirty="0"/>
+          </a:p>
+        </p:txBody>
+      </p:sp>
+      <p:sp>
+        <p:nvSpPr>
+          <p:cNvPr id="4" name="Text 2"/>
+          <p:cNvSpPr/>
+          <p:nvPr/>
+        </p:nvSpPr>
+        <p:spPr>
+          <a:xfrm>
+            <a:off x="640080" y="841248"/>
+            <a:ext cx="10012680" cy="475488"/>
+          </a:xfrm>
+          <a:prstGeom prst="rect">
+            <a:avLst/>
+          </a:prstGeom>
+          <a:noFill/>
+          <a:ln/>
+        </p:spPr>
+        <p:txBody>
+          <a:bodyPr wrap="square" lIns="0" tIns="0" rIns="0" bIns="0" rtlCol="0" anchor="ctr">
+            <a:normAutofit/>
+          </a:bodyPr>
+          <a:lstStyle/>
+          <a:p>
+            <a:pPr indent="0" marL="0">
+              <a:buNone/>
+            </a:pPr>
+            <a:r>
+              <a:rPr lang="en-US" sz="3100" b="1" dirty="0">
+                <a:solidFill>
+                  <a:srgbClr val="11162B"/>
+                </a:solidFill>
+                <a:latin typeface="Aptos Display" pitchFamily="34" charset="0"/>
+                <a:ea typeface="Aptos Display" pitchFamily="34" charset="-122"/>
+                <a:cs typeface="Aptos Display" pitchFamily="34" charset="-120"/>
+              </a:rPr>
+              <a:t>Challenges with Agents</a:t>
+            </a:r>
+            <a:endParaRPr lang="en-US" sz="3100" dirty="0"/>
+          </a:p>
+        </p:txBody>
+      </p:sp>
+      <p:sp>
+        <p:nvSpPr>
+          <p:cNvPr id="5" name="Shape 3"/>
+          <p:cNvSpPr/>
+          <p:nvPr/>
+        </p:nvSpPr>
+        <p:spPr>
+          <a:xfrm>
+            <a:off x="10857220" y="548640"/>
+            <a:ext cx="164592" cy="197510"/>
+          </a:xfrm>
+          <a:prstGeom prst="line">
+            <a:avLst/>
+          </a:prstGeom>
+          <a:noFill/>
+          <a:ln w="25400">
+            <a:solidFill>
+              <a:srgbClr val="11162B"/>
+            </a:solidFill>
+            <a:prstDash val="solid"/>
+          </a:ln>
+        </p:spPr>
+      </p:sp>
+      <p:sp>
+        <p:nvSpPr>
+          <p:cNvPr id="6" name="Shape 4"/>
+          <p:cNvSpPr/>
+          <p:nvPr/>
+        </p:nvSpPr>
+        <p:spPr>
+          <a:xfrm>
+            <a:off x="11034979" y="542056"/>
+            <a:ext cx="158008" cy="164592"/>
+          </a:xfrm>
+          <a:prstGeom prst="line">
+            <a:avLst/>
+          </a:prstGeom>
+          <a:noFill/>
+          <a:ln w="25400">
+            <a:solidFill>
+              <a:srgbClr val="11162B"/>
+            </a:solidFill>
+            <a:prstDash val="solid"/>
+          </a:ln>
+        </p:spPr>
+      </p:sp>
+      <p:sp>
+        <p:nvSpPr>
+          <p:cNvPr id="7" name="Shape 5"/>
+          <p:cNvSpPr/>
+          <p:nvPr/>
+        </p:nvSpPr>
+        <p:spPr>
+          <a:xfrm>
+            <a:off x="11199571" y="502554"/>
+            <a:ext cx="158008" cy="197510"/>
+          </a:xfrm>
+          <a:prstGeom prst="line">
+            <a:avLst/>
+          </a:prstGeom>
+          <a:noFill/>
+          <a:ln w="25400">
+            <a:solidFill>
+              <a:srgbClr val="11162B"/>
+            </a:solidFill>
+            <a:prstDash val="solid"/>
+          </a:ln>
+        </p:spPr>
+      </p:sp>
+      <p:sp>
+        <p:nvSpPr>
+          <p:cNvPr id="8" name="Shape 6"/>
+          <p:cNvSpPr/>
+          <p:nvPr/>
+        </p:nvSpPr>
+        <p:spPr>
+          <a:xfrm>
+            <a:off x="11199571" y="713232"/>
+            <a:ext cx="158008" cy="184343"/>
+          </a:xfrm>
+          <a:prstGeom prst="line">
+            <a:avLst/>
+          </a:prstGeom>
+          <a:noFill/>
+          <a:ln w="25400">
+            <a:solidFill>
+              <a:srgbClr val="11162B"/>
+            </a:solidFill>
+            <a:prstDash val="dash"/>
+          </a:ln>
+        </p:spPr>
+      </p:sp>
+      <p:sp>
+        <p:nvSpPr>
+          <p:cNvPr id="9" name="Shape 7"/>
+          <p:cNvSpPr/>
+          <p:nvPr/>
+        </p:nvSpPr>
+        <p:spPr>
+          <a:xfrm>
+            <a:off x="10824301" y="726399"/>
+            <a:ext cx="98755" cy="98755"/>
+          </a:xfrm>
+          <a:prstGeom prst="ellipse">
+            <a:avLst/>
+          </a:prstGeom>
+          <a:solidFill>
+            <a:srgbClr val="E4F7FB"/>
+          </a:solidFill>
+          <a:ln w="10160">
+            <a:solidFill>
+              <a:srgbClr val="11162B"/>
+            </a:solidFill>
+            <a:prstDash val="solid"/>
+          </a:ln>
+        </p:spPr>
+      </p:sp>
+      <p:sp>
+        <p:nvSpPr>
+          <p:cNvPr id="10" name="Shape 8"/>
+          <p:cNvSpPr/>
+          <p:nvPr/>
+        </p:nvSpPr>
+        <p:spPr>
+          <a:xfrm>
+            <a:off x="11008644" y="502554"/>
+            <a:ext cx="98755" cy="98755"/>
+          </a:xfrm>
+          <a:prstGeom prst="ellipse">
+            <a:avLst/>
+          </a:prstGeom>
+          <a:solidFill>
+            <a:srgbClr val="E4F7FB"/>
+          </a:solidFill>
+          <a:ln w="10160">
+            <a:solidFill>
+              <a:srgbClr val="11162B"/>
+            </a:solidFill>
+            <a:prstDash val="solid"/>
+          </a:ln>
+        </p:spPr>
+      </p:sp>
+      <p:sp>
+        <p:nvSpPr>
+          <p:cNvPr id="11" name="Shape 9"/>
+          <p:cNvSpPr/>
+          <p:nvPr/>
+        </p:nvSpPr>
+        <p:spPr>
+          <a:xfrm>
+            <a:off x="11179820" y="700065"/>
+            <a:ext cx="98755" cy="98755"/>
+          </a:xfrm>
+          <a:prstGeom prst="ellipse">
+            <a:avLst/>
+          </a:prstGeom>
+          <a:solidFill>
+            <a:srgbClr val="16C7E8"/>
+          </a:solidFill>
+          <a:ln w="10160">
+            <a:solidFill>
+              <a:srgbClr val="11162B"/>
+            </a:solidFill>
+            <a:prstDash val="solid"/>
+          </a:ln>
+        </p:spPr>
+      </p:sp>
+      <p:sp>
+        <p:nvSpPr>
+          <p:cNvPr id="12" name="Shape 10"/>
+          <p:cNvSpPr/>
+          <p:nvPr/>
+        </p:nvSpPr>
+        <p:spPr>
+          <a:xfrm>
+            <a:off x="11350996" y="463052"/>
+            <a:ext cx="98755" cy="98755"/>
+          </a:xfrm>
+          <a:prstGeom prst="ellipse">
+            <a:avLst/>
+          </a:prstGeom>
+          <a:solidFill>
+            <a:srgbClr val="E4F7FB"/>
+          </a:solidFill>
+          <a:ln w="10160">
+            <a:solidFill>
+              <a:srgbClr val="11162B"/>
+            </a:solidFill>
+            <a:prstDash val="solid"/>
+          </a:ln>
+        </p:spPr>
+      </p:sp>
+      <p:sp>
+        <p:nvSpPr>
+          <p:cNvPr id="13" name="Shape 11"/>
+          <p:cNvSpPr/>
+          <p:nvPr/>
+        </p:nvSpPr>
+        <p:spPr>
+          <a:xfrm>
+            <a:off x="11377331" y="923910"/>
+            <a:ext cx="98755" cy="98755"/>
+          </a:xfrm>
+          <a:prstGeom prst="ellipse">
+            <a:avLst/>
+          </a:prstGeom>
+          <a:solidFill>
+            <a:srgbClr val="E4F7FB"/>
+          </a:solidFill>
+          <a:ln w="10160">
+            <a:solidFill>
+              <a:srgbClr val="11162B"/>
+            </a:solidFill>
+            <a:prstDash val="solid"/>
+          </a:ln>
+        </p:spPr>
+      </p:sp>
+      <p:sp>
+        <p:nvSpPr>
+          <p:cNvPr id="14" name="Shape 12"/>
+          <p:cNvSpPr/>
+          <p:nvPr/>
+        </p:nvSpPr>
+        <p:spPr>
+          <a:xfrm>
+            <a:off x="11612880" y="457200"/>
+            <a:ext cx="329184" cy="329184"/>
+          </a:xfrm>
+          <a:prstGeom prst="ellipse">
+            <a:avLst/>
+          </a:prstGeom>
+          <a:solidFill>
+            <a:srgbClr val="16C7E8"/>
+          </a:solidFill>
+          <a:ln/>
+        </p:spPr>
+      </p:sp>
+      <p:sp>
+        <p:nvSpPr>
+          <p:cNvPr id="15" name="Text 13"/>
+          <p:cNvSpPr/>
+          <p:nvPr/>
+        </p:nvSpPr>
+        <p:spPr>
+          <a:xfrm>
+            <a:off x="11612880" y="553212"/>
+            <a:ext cx="329184" cy="100584"/>
+          </a:xfrm>
+          <a:prstGeom prst="rect">
+            <a:avLst/>
+          </a:prstGeom>
+          <a:noFill/>
+          <a:ln/>
+        </p:spPr>
+        <p:txBody>
+          <a:bodyPr wrap="square" lIns="0" tIns="0" rIns="0" bIns="0" rtlCol="0" anchor="ctr"/>
+          <a:lstStyle/>
+          <a:p>
+            <a:pPr algn="ctr" indent="0" marL="0">
+              <a:buNone/>
+            </a:pPr>
+            <a:r>
+              <a:rPr lang="en-US" sz="850" b="1" dirty="0">
+                <a:solidFill>
+                  <a:srgbClr val="11162B"/>
+                </a:solidFill>
+                <a:latin typeface="Aptos" pitchFamily="34" charset="0"/>
+                <a:ea typeface="Aptos" pitchFamily="34" charset="-122"/>
+                <a:cs typeface="Aptos" pitchFamily="34" charset="-120"/>
+              </a:rPr>
+              <a:t>02</a:t>
+            </a:r>
+            <a:endParaRPr lang="en-US" sz="850" dirty="0"/>
+          </a:p>
+        </p:txBody>
+      </p:sp>
+      <p:sp>
+        <p:nvSpPr>
+          <p:cNvPr id="16" name="Shape 14"/>
+          <p:cNvSpPr/>
+          <p:nvPr/>
+        </p:nvSpPr>
+        <p:spPr>
+          <a:xfrm>
+            <a:off x="9829800" y="1005840"/>
+            <a:ext cx="2148840" cy="2148840"/>
+          </a:xfrm>
+          <a:prstGeom prst="ellipse">
+            <a:avLst/>
+          </a:prstGeom>
+          <a:solidFill>
+            <a:srgbClr val="E4F7FB"/>
+          </a:solidFill>
+          <a:ln/>
+        </p:spPr>
+      </p:sp>
+      <p:sp>
+        <p:nvSpPr>
+          <p:cNvPr id="17" name="Shape 15"/>
+          <p:cNvSpPr/>
+          <p:nvPr/>
+        </p:nvSpPr>
+        <p:spPr>
+          <a:xfrm>
+            <a:off x="640080" y="1389888"/>
+            <a:ext cx="3477768" cy="2299716"/>
+          </a:xfrm>
+          <a:prstGeom prst="roundRect">
+            <a:avLst>
+              <a:gd name="adj" fmla="val 3181"/>
+            </a:avLst>
+          </a:prstGeom>
+          <a:solidFill>
+            <a:srgbClr val="E4F7FB"/>
+          </a:solidFill>
+          <a:ln w="10160">
+            <a:solidFill>
+              <a:srgbClr val="E4F7FB"/>
+            </a:solidFill>
+            <a:prstDash val="solid"/>
+          </a:ln>
+          <a:effectLst>
+            <a:outerShdw sx="100000" sy="100000" kx="0" ky="0" algn="bl" rotWithShape="0" blurRad="50800" dist="19050" dir="8100000">
+              <a:srgbClr val="111827">
+                <a:alpha val="11000"/>
+              </a:srgbClr>
+            </a:outerShdw>
+          </a:effectLst>
+        </p:spPr>
+      </p:sp>
+      <p:sp>
+        <p:nvSpPr>
+          <p:cNvPr id="18" name="Shape 16"/>
+          <p:cNvSpPr/>
+          <p:nvPr/>
+        </p:nvSpPr>
+        <p:spPr>
+          <a:xfrm>
+            <a:off x="822960" y="1572768"/>
+            <a:ext cx="384048" cy="384048"/>
+          </a:xfrm>
+          <a:prstGeom prst="ellipse">
+            <a:avLst/>
+          </a:prstGeom>
+          <a:solidFill>
+            <a:srgbClr val="16C7E8"/>
+          </a:solidFill>
+          <a:ln/>
+        </p:spPr>
+      </p:sp>
+      <p:sp>
+        <p:nvSpPr>
+          <p:cNvPr id="19" name="Text 17"/>
+          <p:cNvSpPr/>
+          <p:nvPr/>
+        </p:nvSpPr>
+        <p:spPr>
+          <a:xfrm>
+            <a:off x="822960" y="1682496"/>
+            <a:ext cx="384048" cy="109728"/>
+          </a:xfrm>
+          <a:prstGeom prst="rect">
+            <a:avLst/>
+          </a:prstGeom>
+          <a:noFill/>
+          <a:ln/>
+        </p:spPr>
+        <p:txBody>
+          <a:bodyPr wrap="square" lIns="0" tIns="0" rIns="0" bIns="0" rtlCol="0" anchor="ctr"/>
+          <a:lstStyle/>
+          <a:p>
+            <a:pPr algn="ctr" indent="0" marL="0">
+              <a:buNone/>
+            </a:pPr>
+            <a:r>
+              <a:rPr lang="en-US" sz="950" b="1" dirty="0">
+                <a:solidFill>
+                  <a:srgbClr val="11162B"/>
+                </a:solidFill>
+                <a:latin typeface="Aptos" pitchFamily="34" charset="0"/>
+                <a:ea typeface="Aptos" pitchFamily="34" charset="-122"/>
+                <a:cs typeface="Aptos" pitchFamily="34" charset="-120"/>
+              </a:rPr>
+              <a:t>1</a:t>
+            </a:r>
+            <a:endParaRPr lang="en-US" sz="950" dirty="0"/>
+          </a:p>
+        </p:txBody>
+      </p:sp>
+      <p:sp>
+        <p:nvSpPr>
+          <p:cNvPr id="20" name="Text 18"/>
+          <p:cNvSpPr/>
+          <p:nvPr/>
+        </p:nvSpPr>
+        <p:spPr>
+          <a:xfrm>
+            <a:off x="1335024" y="1554480"/>
+            <a:ext cx="2581656" cy="493776"/>
+          </a:xfrm>
+          <a:prstGeom prst="rect">
+            <a:avLst/>
+          </a:prstGeom>
+          <a:noFill/>
+          <a:ln/>
+        </p:spPr>
+        <p:txBody>
+          <a:bodyPr wrap="square" lIns="0" tIns="0" rIns="0" bIns="0" rtlCol="0" anchor="ctr">
+            <a:normAutofit/>
+          </a:bodyPr>
+          <a:lstStyle/>
+          <a:p>
+            <a:pPr indent="0" marL="0">
+              <a:buNone/>
+            </a:pPr>
+            <a:r>
+              <a:rPr lang="en-US" sz="1800" b="1" dirty="0">
+                <a:solidFill>
+                  <a:srgbClr val="11162B"/>
+                </a:solidFill>
+                <a:latin typeface="Aptos Display" pitchFamily="34" charset="0"/>
+                <a:ea typeface="Aptos Display" pitchFamily="34" charset="-122"/>
+                <a:cs typeface="Aptos Display" pitchFamily="34" charset="-120"/>
+              </a:rPr>
+              <a:t>Many steps</a:t>
+            </a:r>
+            <a:endParaRPr lang="en-US" sz="1800" dirty="0"/>
+          </a:p>
+        </p:txBody>
+      </p:sp>
+      <p:sp>
+        <p:nvSpPr>
+          <p:cNvPr id="21" name="Text 19"/>
+          <p:cNvSpPr/>
+          <p:nvPr/>
+        </p:nvSpPr>
+        <p:spPr>
+          <a:xfrm>
+            <a:off x="896112" y="2194560"/>
+            <a:ext cx="2965704" cy="1312164"/>
+          </a:xfrm>
+          <a:prstGeom prst="rect">
+            <a:avLst/>
+          </a:prstGeom>
+          <a:noFill/>
+          <a:ln/>
+        </p:spPr>
+        <p:txBody>
+          <a:bodyPr wrap="square" lIns="0" tIns="0" rIns="0" bIns="0" rtlCol="0" anchor="t">
+            <a:normAutofit/>
+          </a:bodyPr>
+          <a:lstStyle/>
+          <a:p>
+            <a:pPr marL="342900" indent="-342900">
+              <a:buSzPct val="100000"/>
+              <a:buChar char="•"/>
+            </a:pPr>
+            <a:r>
+              <a:rPr lang="en-US" sz="1420" dirty="0">
+                <a:solidFill>
+                  <a:srgbClr val="151B31"/>
+                </a:solidFill>
+                <a:latin typeface="Aptos" pitchFamily="34" charset="0"/>
+                <a:ea typeface="Aptos" pitchFamily="34" charset="-122"/>
+                <a:cs typeface="Aptos" pitchFamily="34" charset="-120"/>
+              </a:rPr>
+              <a:t>A single response can involve enough operations that the complete path is difficult to follow</a:t>
+            </a:r>
+            <a:endParaRPr lang="en-US" sz="1420" dirty="0"/>
+          </a:p>
+        </p:txBody>
+      </p:sp>
+      <p:sp>
+        <p:nvSpPr>
+          <p:cNvPr id="22" name="Shape 20"/>
+          <p:cNvSpPr/>
+          <p:nvPr/>
+        </p:nvSpPr>
+        <p:spPr>
+          <a:xfrm>
+            <a:off x="4355592" y="1389888"/>
+            <a:ext cx="3477768" cy="2299716"/>
+          </a:xfrm>
+          <a:prstGeom prst="roundRect">
+            <a:avLst>
+              <a:gd name="adj" fmla="val 3181"/>
+            </a:avLst>
+          </a:prstGeom>
+          <a:solidFill>
+            <a:srgbClr val="FFFFFF"/>
+          </a:solidFill>
+          <a:ln w="10160">
+            <a:solidFill>
+              <a:srgbClr val="E4F7FB"/>
+            </a:solidFill>
+            <a:prstDash val="solid"/>
+          </a:ln>
+          <a:effectLst>
+            <a:outerShdw sx="100000" sy="100000" kx="0" ky="0" algn="bl" rotWithShape="0" blurRad="50800" dist="19050" dir="8100000">
+              <a:srgbClr val="111827">
+                <a:alpha val="11000"/>
+              </a:srgbClr>
+            </a:outerShdw>
+          </a:effectLst>
+        </p:spPr>
+      </p:sp>
+      <p:sp>
+        <p:nvSpPr>
+          <p:cNvPr id="23" name="Shape 21"/>
+          <p:cNvSpPr/>
+          <p:nvPr/>
+        </p:nvSpPr>
+        <p:spPr>
+          <a:xfrm>
+            <a:off x="4538472" y="1572768"/>
+            <a:ext cx="384048" cy="384048"/>
+          </a:xfrm>
+          <a:prstGeom prst="ellipse">
+            <a:avLst/>
+          </a:prstGeom>
+          <a:solidFill>
+            <a:srgbClr val="16C7E8"/>
+          </a:solidFill>
+          <a:ln/>
+        </p:spPr>
+      </p:sp>
+      <p:sp>
+        <p:nvSpPr>
+          <p:cNvPr id="24" name="Text 22"/>
+          <p:cNvSpPr/>
+          <p:nvPr/>
+        </p:nvSpPr>
+        <p:spPr>
+          <a:xfrm>
+            <a:off x="4538472" y="1682496"/>
+            <a:ext cx="384048" cy="109728"/>
+          </a:xfrm>
+          <a:prstGeom prst="rect">
+            <a:avLst/>
+          </a:prstGeom>
+          <a:noFill/>
+          <a:ln/>
+        </p:spPr>
+        <p:txBody>
+          <a:bodyPr wrap="square" lIns="0" tIns="0" rIns="0" bIns="0" rtlCol="0" anchor="ctr"/>
+          <a:lstStyle/>
+          <a:p>
+            <a:pPr algn="ctr" indent="0" marL="0">
+              <a:buNone/>
+            </a:pPr>
+            <a:r>
+              <a:rPr lang="en-US" sz="950" b="1" dirty="0">
+                <a:solidFill>
+                  <a:srgbClr val="11162B"/>
+                </a:solidFill>
+                <a:latin typeface="Aptos" pitchFamily="34" charset="0"/>
+                <a:ea typeface="Aptos" pitchFamily="34" charset="-122"/>
+                <a:cs typeface="Aptos" pitchFamily="34" charset="-120"/>
+              </a:rPr>
+              <a:t>2</a:t>
+            </a:r>
+            <a:endParaRPr lang="en-US" sz="950" dirty="0"/>
+          </a:p>
+        </p:txBody>
+      </p:sp>
+      <p:sp>
+        <p:nvSpPr>
+          <p:cNvPr id="25" name="Text 23"/>
+          <p:cNvSpPr/>
+          <p:nvPr/>
+        </p:nvSpPr>
+        <p:spPr>
+          <a:xfrm>
+            <a:off x="5050536" y="1554480"/>
+            <a:ext cx="2581656" cy="493776"/>
+          </a:xfrm>
+          <a:prstGeom prst="rect">
+            <a:avLst/>
+          </a:prstGeom>
+          <a:noFill/>
+          <a:ln/>
+        </p:spPr>
+        <p:txBody>
+          <a:bodyPr wrap="square" lIns="0" tIns="0" rIns="0" bIns="0" rtlCol="0" anchor="ctr">
+            <a:normAutofit/>
+          </a:bodyPr>
+          <a:lstStyle/>
+          <a:p>
+            <a:pPr indent="0" marL="0">
+              <a:buNone/>
+            </a:pPr>
+            <a:r>
+              <a:rPr lang="en-US" sz="1800" b="1" dirty="0">
+                <a:solidFill>
+                  <a:srgbClr val="11162B"/>
+                </a:solidFill>
+                <a:latin typeface="Aptos Display" pitchFamily="34" charset="0"/>
+                <a:ea typeface="Aptos Display" pitchFamily="34" charset="-122"/>
+                <a:cs typeface="Aptos Display" pitchFamily="34" charset="-120"/>
+              </a:rPr>
+              <a:t>Variable sequence</a:t>
+            </a:r>
+            <a:endParaRPr lang="en-US" sz="1800" dirty="0"/>
+          </a:p>
+        </p:txBody>
+      </p:sp>
+      <p:sp>
+        <p:nvSpPr>
+          <p:cNvPr id="26" name="Text 24"/>
+          <p:cNvSpPr/>
+          <p:nvPr/>
+        </p:nvSpPr>
+        <p:spPr>
+          <a:xfrm>
+            <a:off x="4611624" y="2194560"/>
+            <a:ext cx="2965704" cy="1312164"/>
+          </a:xfrm>
+          <a:prstGeom prst="rect">
+            <a:avLst/>
+          </a:prstGeom>
+          <a:noFill/>
+          <a:ln/>
+        </p:spPr>
+        <p:txBody>
+          <a:bodyPr wrap="square" lIns="0" tIns="0" rIns="0" bIns="0" rtlCol="0" anchor="t">
+            <a:normAutofit/>
+          </a:bodyPr>
+          <a:lstStyle/>
+          <a:p>
+            <a:pPr marL="342900" indent="-342900">
+              <a:buSzPct val="100000"/>
+              <a:buChar char="•"/>
+            </a:pPr>
+            <a:r>
+              <a:rPr lang="en-US" sz="1420" dirty="0">
+                <a:solidFill>
+                  <a:srgbClr val="151B31"/>
+                </a:solidFill>
+                <a:latin typeface="Aptos" pitchFamily="34" charset="0"/>
+                <a:ea typeface="Aptos" pitchFamily="34" charset="-122"/>
+                <a:cs typeface="Aptos" pitchFamily="34" charset="-120"/>
+              </a:rPr>
+              <a:t>The steps and their order can change based on the user's input</a:t>
+            </a:r>
+            <a:endParaRPr lang="en-US" sz="1420" dirty="0"/>
+          </a:p>
+        </p:txBody>
+      </p:sp>
+      <p:sp>
+        <p:nvSpPr>
+          <p:cNvPr id="27" name="Shape 25"/>
+          <p:cNvSpPr/>
+          <p:nvPr/>
+        </p:nvSpPr>
+        <p:spPr>
+          <a:xfrm>
+            <a:off x="8071104" y="1389888"/>
+            <a:ext cx="3477768" cy="2299716"/>
+          </a:xfrm>
+          <a:prstGeom prst="roundRect">
+            <a:avLst>
+              <a:gd name="adj" fmla="val 3181"/>
+            </a:avLst>
+          </a:prstGeom>
+          <a:solidFill>
+            <a:srgbClr val="FFFFFF"/>
+          </a:solidFill>
+          <a:ln w="10160">
+            <a:solidFill>
+              <a:srgbClr val="E4F7FB"/>
+            </a:solidFill>
+            <a:prstDash val="solid"/>
+          </a:ln>
+          <a:effectLst>
+            <a:outerShdw sx="100000" sy="100000" kx="0" ky="0" algn="bl" rotWithShape="0" blurRad="50800" dist="19050" dir="8100000">
+              <a:srgbClr val="111827">
+                <a:alpha val="11000"/>
+              </a:srgbClr>
+            </a:outerShdw>
+          </a:effectLst>
+        </p:spPr>
+      </p:sp>
+      <p:sp>
+        <p:nvSpPr>
+          <p:cNvPr id="28" name="Shape 26"/>
+          <p:cNvSpPr/>
+          <p:nvPr/>
+        </p:nvSpPr>
+        <p:spPr>
+          <a:xfrm>
+            <a:off x="8253984" y="1572768"/>
+            <a:ext cx="384048" cy="384048"/>
+          </a:xfrm>
+          <a:prstGeom prst="ellipse">
+            <a:avLst/>
+          </a:prstGeom>
+          <a:solidFill>
+            <a:srgbClr val="16C7E8"/>
+          </a:solidFill>
+          <a:ln/>
+        </p:spPr>
+      </p:sp>
+      <p:sp>
+        <p:nvSpPr>
+          <p:cNvPr id="29" name="Text 27"/>
+          <p:cNvSpPr/>
+          <p:nvPr/>
+        </p:nvSpPr>
+        <p:spPr>
+          <a:xfrm>
+            <a:off x="8253984" y="1682496"/>
+            <a:ext cx="384048" cy="109728"/>
+          </a:xfrm>
+          <a:prstGeom prst="rect">
+            <a:avLst/>
+          </a:prstGeom>
+          <a:noFill/>
+          <a:ln/>
+        </p:spPr>
+        <p:txBody>
+          <a:bodyPr wrap="square" lIns="0" tIns="0" rIns="0" bIns="0" rtlCol="0" anchor="ctr"/>
+          <a:lstStyle/>
+          <a:p>
+            <a:pPr algn="ctr" indent="0" marL="0">
+              <a:buNone/>
+            </a:pPr>
+            <a:r>
+              <a:rPr lang="en-US" sz="950" b="1" dirty="0">
+                <a:solidFill>
+                  <a:srgbClr val="11162B"/>
+                </a:solidFill>
+                <a:latin typeface="Aptos" pitchFamily="34" charset="0"/>
+                <a:ea typeface="Aptos" pitchFamily="34" charset="-122"/>
+                <a:cs typeface="Aptos" pitchFamily="34" charset="-120"/>
+              </a:rPr>
+              <a:t>3</a:t>
+            </a:r>
+            <a:endParaRPr lang="en-US" sz="950" dirty="0"/>
+          </a:p>
+        </p:txBody>
+      </p:sp>
+      <p:sp>
+        <p:nvSpPr>
+          <p:cNvPr id="30" name="Text 28"/>
+          <p:cNvSpPr/>
+          <p:nvPr/>
+        </p:nvSpPr>
+        <p:spPr>
+          <a:xfrm>
+            <a:off x="8766048" y="1554480"/>
+            <a:ext cx="2581656" cy="493776"/>
+          </a:xfrm>
+          <a:prstGeom prst="rect">
+            <a:avLst/>
+          </a:prstGeom>
+          <a:noFill/>
+          <a:ln/>
+        </p:spPr>
+        <p:txBody>
+          <a:bodyPr wrap="square" lIns="0" tIns="0" rIns="0" bIns="0" rtlCol="0" anchor="ctr">
+            <a:normAutofit/>
+          </a:bodyPr>
+          <a:lstStyle/>
+          <a:p>
+            <a:pPr indent="0" marL="0">
+              <a:buNone/>
+            </a:pPr>
+            <a:r>
+              <a:rPr lang="en-US" sz="1800" b="1" dirty="0">
+                <a:solidFill>
+                  <a:srgbClr val="11162B"/>
+                </a:solidFill>
+                <a:latin typeface="Aptos Display" pitchFamily="34" charset="0"/>
+                <a:ea typeface="Aptos Display" pitchFamily="34" charset="-122"/>
+                <a:cs typeface="Aptos Display" pitchFamily="34" charset="-120"/>
+              </a:rPr>
+              <a:t>Large stage data</a:t>
+            </a:r>
+            <a:endParaRPr lang="en-US" sz="1800" dirty="0"/>
+          </a:p>
+        </p:txBody>
+      </p:sp>
+      <p:sp>
+        <p:nvSpPr>
+          <p:cNvPr id="31" name="Text 29"/>
+          <p:cNvSpPr/>
+          <p:nvPr/>
+        </p:nvSpPr>
+        <p:spPr>
+          <a:xfrm>
+            <a:off x="8327136" y="2194560"/>
+            <a:ext cx="2965704" cy="1312164"/>
+          </a:xfrm>
+          <a:prstGeom prst="rect">
+            <a:avLst/>
+          </a:prstGeom>
+          <a:noFill/>
+          <a:ln/>
+        </p:spPr>
+        <p:txBody>
+          <a:bodyPr wrap="square" lIns="0" tIns="0" rIns="0" bIns="0" rtlCol="0" anchor="t">
+            <a:normAutofit/>
+          </a:bodyPr>
+          <a:lstStyle/>
+          <a:p>
+            <a:pPr marL="342900" indent="-342900">
+              <a:buSzPct val="100000"/>
+              <a:buChar char="•"/>
+            </a:pPr>
+            <a:r>
+              <a:rPr lang="en-US" sz="1420" dirty="0">
+                <a:solidFill>
+                  <a:srgbClr val="151B31"/>
+                </a:solidFill>
+                <a:latin typeface="Aptos" pitchFamily="34" charset="0"/>
+                <a:ea typeface="Aptos" pitchFamily="34" charset="-122"/>
+                <a:cs typeface="Aptos" pitchFamily="34" charset="-120"/>
+              </a:rPr>
+              <a:t>Inputs and outputs at each stage can require detailed inspection</a:t>
+            </a:r>
+            <a:endParaRPr lang="en-US" sz="1420" dirty="0"/>
+          </a:p>
+        </p:txBody>
+      </p:sp>
+      <p:sp>
+        <p:nvSpPr>
+          <p:cNvPr id="32" name="Shape 30"/>
+          <p:cNvSpPr/>
+          <p:nvPr/>
+        </p:nvSpPr>
+        <p:spPr>
+          <a:xfrm>
+            <a:off x="2378964" y="3945636"/>
+            <a:ext cx="3477768" cy="2299716"/>
+          </a:xfrm>
+          <a:prstGeom prst="roundRect">
+            <a:avLst>
+              <a:gd name="adj" fmla="val 3181"/>
+            </a:avLst>
+          </a:prstGeom>
+          <a:solidFill>
+            <a:srgbClr val="FFFFFF"/>
+          </a:solidFill>
+          <a:ln w="10160">
+            <a:solidFill>
+              <a:srgbClr val="E4F7FB"/>
+            </a:solidFill>
+            <a:prstDash val="solid"/>
+          </a:ln>
+          <a:effectLst>
+            <a:outerShdw sx="100000" sy="100000" kx="0" ky="0" algn="bl" rotWithShape="0" blurRad="50800" dist="19050" dir="8100000">
+              <a:srgbClr val="111827">
+                <a:alpha val="11000"/>
+              </a:srgbClr>
+            </a:outerShdw>
+          </a:effectLst>
+        </p:spPr>
+      </p:sp>
+      <p:sp>
+        <p:nvSpPr>
+          <p:cNvPr id="33" name="Shape 31"/>
+          <p:cNvSpPr/>
+          <p:nvPr/>
+        </p:nvSpPr>
+        <p:spPr>
+          <a:xfrm>
+            <a:off x="2561844" y="4128516"/>
+            <a:ext cx="384048" cy="384048"/>
+          </a:xfrm>
+          <a:prstGeom prst="ellipse">
+            <a:avLst/>
+          </a:prstGeom>
+          <a:solidFill>
+            <a:srgbClr val="8B5CF6"/>
+          </a:solidFill>
+          <a:ln/>
+        </p:spPr>
+      </p:sp>
+      <p:sp>
+        <p:nvSpPr>
+          <p:cNvPr id="34" name="Text 32"/>
+          <p:cNvSpPr/>
+          <p:nvPr/>
+        </p:nvSpPr>
+        <p:spPr>
+          <a:xfrm>
+            <a:off x="2561844" y="4238244"/>
+            <a:ext cx="384048" cy="109728"/>
+          </a:xfrm>
+          <a:prstGeom prst="rect">
+            <a:avLst/>
+          </a:prstGeom>
+          <a:noFill/>
+          <a:ln/>
+        </p:spPr>
+        <p:txBody>
+          <a:bodyPr wrap="square" lIns="0" tIns="0" rIns="0" bIns="0" rtlCol="0" anchor="ctr"/>
+          <a:lstStyle/>
+          <a:p>
+            <a:pPr algn="ctr" indent="0" marL="0">
+              <a:buNone/>
+            </a:pPr>
+            <a:r>
+              <a:rPr lang="en-US" sz="950" b="1" dirty="0">
+                <a:solidFill>
+                  <a:srgbClr val="11162B"/>
+                </a:solidFill>
+                <a:latin typeface="Aptos" pitchFamily="34" charset="0"/>
+                <a:ea typeface="Aptos" pitchFamily="34" charset="-122"/>
+                <a:cs typeface="Aptos" pitchFamily="34" charset="-120"/>
+              </a:rPr>
+              <a:t>4</a:t>
+            </a:r>
+            <a:endParaRPr lang="en-US" sz="950" dirty="0"/>
+          </a:p>
+        </p:txBody>
+      </p:sp>
+      <p:sp>
+        <p:nvSpPr>
+          <p:cNvPr id="35" name="Text 33"/>
+          <p:cNvSpPr/>
+          <p:nvPr/>
+        </p:nvSpPr>
+        <p:spPr>
+          <a:xfrm>
+            <a:off x="3073908" y="4110228"/>
+            <a:ext cx="2581656" cy="493776"/>
+          </a:xfrm>
+          <a:prstGeom prst="rect">
+            <a:avLst/>
+          </a:prstGeom>
+          <a:noFill/>
+          <a:ln/>
+        </p:spPr>
+        <p:txBody>
+          <a:bodyPr wrap="square" lIns="0" tIns="0" rIns="0" bIns="0" rtlCol="0" anchor="ctr">
+            <a:normAutofit/>
+          </a:bodyPr>
+          <a:lstStyle/>
+          <a:p>
+            <a:pPr indent="0" marL="0">
+              <a:buNone/>
+            </a:pPr>
+            <a:r>
+              <a:rPr lang="en-US" sz="1800" b="1" dirty="0">
+                <a:solidFill>
+                  <a:srgbClr val="11162B"/>
+                </a:solidFill>
+                <a:latin typeface="Aptos Display" pitchFamily="34" charset="0"/>
+                <a:ea typeface="Aptos Display" pitchFamily="34" charset="-122"/>
+                <a:cs typeface="Aptos Display" pitchFamily="34" charset="-120"/>
+              </a:rPr>
+              <a:t>Nested execution</a:t>
+            </a:r>
+            <a:endParaRPr lang="en-US" sz="1800" dirty="0"/>
+          </a:p>
+        </p:txBody>
+      </p:sp>
+      <p:sp>
+        <p:nvSpPr>
+          <p:cNvPr id="36" name="Text 34"/>
+          <p:cNvSpPr/>
+          <p:nvPr/>
+        </p:nvSpPr>
+        <p:spPr>
+          <a:xfrm>
+            <a:off x="2634996" y="4750308"/>
+            <a:ext cx="2965704" cy="1312164"/>
+          </a:xfrm>
+          <a:prstGeom prst="rect">
+            <a:avLst/>
+          </a:prstGeom>
+          <a:noFill/>
+          <a:ln/>
+        </p:spPr>
+        <p:txBody>
+          <a:bodyPr wrap="square" lIns="0" tIns="0" rIns="0" bIns="0" rtlCol="0" anchor="t">
+            <a:normAutofit/>
+          </a:bodyPr>
+          <a:lstStyle/>
+          <a:p>
+            <a:pPr marL="342900" indent="-342900">
+              <a:buSzPct val="100000"/>
+              <a:buChar char="•"/>
+            </a:pPr>
+            <a:r>
+              <a:rPr lang="en-US" sz="1420" dirty="0">
+                <a:solidFill>
+                  <a:srgbClr val="151B31"/>
+                </a:solidFill>
+                <a:latin typeface="Aptos" pitchFamily="34" charset="0"/>
+                <a:ea typeface="Aptos" pitchFamily="34" charset="-122"/>
+                <a:cs typeface="Aptos" pitchFamily="34" charset="-120"/>
+              </a:rPr>
+              <a:t>An agent can call a tool that invokes another process or tool, obscuring where an issue entered the run</a:t>
+            </a:r>
+            <a:endParaRPr lang="en-US" sz="1420" dirty="0"/>
+          </a:p>
+        </p:txBody>
+      </p:sp>
+      <p:sp>
+        <p:nvSpPr>
+          <p:cNvPr id="37" name="Shape 35"/>
+          <p:cNvSpPr/>
+          <p:nvPr/>
+        </p:nvSpPr>
+        <p:spPr>
+          <a:xfrm>
+            <a:off x="6094476" y="3945636"/>
+            <a:ext cx="3477768" cy="2299716"/>
+          </a:xfrm>
+          <a:prstGeom prst="roundRect">
+            <a:avLst>
+              <a:gd name="adj" fmla="val 3181"/>
+            </a:avLst>
+          </a:prstGeom>
+          <a:solidFill>
+            <a:srgbClr val="EEE9FF"/>
+          </a:solidFill>
+          <a:ln w="10160">
+            <a:solidFill>
+              <a:srgbClr val="E4F7FB"/>
+            </a:solidFill>
+            <a:prstDash val="solid"/>
+          </a:ln>
+          <a:effectLst>
+            <a:outerShdw sx="100000" sy="100000" kx="0" ky="0" algn="bl" rotWithShape="0" blurRad="50800" dist="19050" dir="8100000">
+              <a:srgbClr val="111827">
+                <a:alpha val="11000"/>
+              </a:srgbClr>
+            </a:outerShdw>
+          </a:effectLst>
+        </p:spPr>
+      </p:sp>
+      <p:sp>
+        <p:nvSpPr>
+          <p:cNvPr id="38" name="Shape 36"/>
+          <p:cNvSpPr/>
+          <p:nvPr/>
+        </p:nvSpPr>
+        <p:spPr>
+          <a:xfrm>
+            <a:off x="6277356" y="4128516"/>
+            <a:ext cx="384048" cy="384048"/>
+          </a:xfrm>
+          <a:prstGeom prst="ellipse">
+            <a:avLst/>
+          </a:prstGeom>
+          <a:solidFill>
+            <a:srgbClr val="8B5CF6"/>
+          </a:solidFill>
+          <a:ln/>
+        </p:spPr>
+      </p:sp>
+      <p:sp>
+        <p:nvSpPr>
+          <p:cNvPr id="39" name="Text 37"/>
+          <p:cNvSpPr/>
+          <p:nvPr/>
+        </p:nvSpPr>
+        <p:spPr>
+          <a:xfrm>
+            <a:off x="6277356" y="4238244"/>
+            <a:ext cx="384048" cy="109728"/>
+          </a:xfrm>
+          <a:prstGeom prst="rect">
+            <a:avLst/>
+          </a:prstGeom>
+          <a:noFill/>
+          <a:ln/>
+        </p:spPr>
+        <p:txBody>
+          <a:bodyPr wrap="square" lIns="0" tIns="0" rIns="0" bIns="0" rtlCol="0" anchor="ctr"/>
+          <a:lstStyle/>
+          <a:p>
+            <a:pPr algn="ctr" indent="0" marL="0">
+              <a:buNone/>
+            </a:pPr>
+            <a:r>
+              <a:rPr lang="en-US" sz="950" b="1" dirty="0">
+                <a:solidFill>
+                  <a:srgbClr val="11162B"/>
+                </a:solidFill>
+                <a:latin typeface="Aptos" pitchFamily="34" charset="0"/>
+                <a:ea typeface="Aptos" pitchFamily="34" charset="-122"/>
+                <a:cs typeface="Aptos" pitchFamily="34" charset="-120"/>
+              </a:rPr>
+              <a:t>5</a:t>
+            </a:r>
+            <a:endParaRPr lang="en-US" sz="950" dirty="0"/>
+          </a:p>
+        </p:txBody>
+      </p:sp>
+      <p:sp>
+        <p:nvSpPr>
+          <p:cNvPr id="40" name="Text 38"/>
+          <p:cNvSpPr/>
+          <p:nvPr/>
+        </p:nvSpPr>
+        <p:spPr>
+          <a:xfrm>
+            <a:off x="6789420" y="4110228"/>
+            <a:ext cx="2581656" cy="493776"/>
+          </a:xfrm>
+          <a:prstGeom prst="rect">
+            <a:avLst/>
+          </a:prstGeom>
+          <a:noFill/>
+          <a:ln/>
+        </p:spPr>
+        <p:txBody>
+          <a:bodyPr wrap="square" lIns="0" tIns="0" rIns="0" bIns="0" rtlCol="0" anchor="ctr">
+            <a:normAutofit/>
+          </a:bodyPr>
+          <a:lstStyle/>
+          <a:p>
+            <a:pPr indent="0" marL="0">
+              <a:buNone/>
+            </a:pPr>
+            <a:r>
+              <a:rPr lang="en-US" sz="1800" b="1" dirty="0">
+                <a:solidFill>
+                  <a:srgbClr val="11162B"/>
+                </a:solidFill>
+                <a:latin typeface="Aptos Display" pitchFamily="34" charset="0"/>
+                <a:ea typeface="Aptos Display" pitchFamily="34" charset="-122"/>
+                <a:cs typeface="Aptos Display" pitchFamily="34" charset="-120"/>
+              </a:rPr>
+              <a:t>Trace the recorded run</a:t>
+            </a:r>
+            <a:endParaRPr lang="en-US" sz="1800" dirty="0"/>
+          </a:p>
+        </p:txBody>
+      </p:sp>
+      <p:sp>
+        <p:nvSpPr>
+          <p:cNvPr id="41" name="Text 39"/>
+          <p:cNvSpPr/>
+          <p:nvPr/>
+        </p:nvSpPr>
+        <p:spPr>
+          <a:xfrm>
+            <a:off x="6350508" y="4750308"/>
+            <a:ext cx="2965704" cy="1312164"/>
+          </a:xfrm>
+          <a:prstGeom prst="rect">
+            <a:avLst/>
+          </a:prstGeom>
+          <a:noFill/>
+          <a:ln/>
+        </p:spPr>
+        <p:txBody>
+          <a:bodyPr wrap="square" lIns="0" tIns="0" rIns="0" bIns="0" rtlCol="0" anchor="t">
+            <a:normAutofit/>
+          </a:bodyPr>
+          <a:lstStyle/>
+          <a:p>
+            <a:pPr marL="342900" indent="-342900">
+              <a:buSzPct val="100000"/>
+              <a:buChar char="•"/>
+            </a:pPr>
+            <a:r>
+              <a:rPr lang="en-US" sz="1420" dirty="0">
+                <a:solidFill>
+                  <a:srgbClr val="151B31"/>
+                </a:solidFill>
+                <a:latin typeface="Aptos" pitchFamily="34" charset="0"/>
+                <a:ea typeface="Aptos" pitchFamily="34" charset="-122"/>
+                <a:cs typeface="Aptos" pitchFamily="34" charset="-120"/>
+              </a:rPr>
+              <a:t>View recorded primitives in invocation order and inspect each stage's inputs and outputs to understand and debug the behavior</a:t>
+            </a:r>
+            <a:endParaRPr lang="en-US" sz="1420" dirty="0"/>
+          </a:p>
+        </p:txBody>
+      </p:sp>
+      <p:sp>
+        <p:nvSpPr>
+          <p:cNvPr id="42" name="Text 40"/>
+          <p:cNvSpPr/>
+          <p:nvPr/>
+        </p:nvSpPr>
+        <p:spPr>
+          <a:xfrm>
+            <a:off x="658368" y="6318504"/>
+            <a:ext cx="10881360" cy="182880"/>
+          </a:xfrm>
+          <a:prstGeom prst="rect">
+            <a:avLst/>
+          </a:prstGeom>
+          <a:noFill/>
+          <a:ln/>
+        </p:spPr>
+        <p:txBody>
+          <a:bodyPr wrap="square" lIns="0" tIns="0" rIns="0" bIns="0" rtlCol="0" anchor="ctr">
+            <a:normAutofit/>
+          </a:bodyPr>
+          <a:lstStyle/>
+          <a:p>
+            <a:pPr indent="0" marL="0">
+              <a:buNone/>
+            </a:pPr>
+            <a:r>
+              <a:rPr lang="en-US" sz="940" dirty="0">
+                <a:solidFill>
+                  <a:srgbClr val="526276"/>
+                </a:solidFill>
+                <a:latin typeface="Aptos" pitchFamily="34" charset="0"/>
+                <a:ea typeface="Aptos" pitchFamily="34" charset="-122"/>
+                <a:cs typeface="Aptos" pitchFamily="34" charset="-120"/>
+              </a:rPr>
+              <a:t>REFERENCE  learn.microsoft.com/azure/foundry/observability/concepts/trace-agent-concept</a:t>
+            </a:r>
+            <a:endParaRPr lang="en-US" sz="940" dirty="0"/>
+          </a:p>
+        </p:txBody>
+      </p:sp>
+      <p:sp>
+        <p:nvSpPr>
+          <p:cNvPr id="43" name="Shape 41"/>
+          <p:cNvSpPr/>
+          <p:nvPr/>
+        </p:nvSpPr>
+        <p:spPr>
+          <a:xfrm>
+            <a:off x="0" y="6793992"/>
+            <a:ext cx="12191695" cy="64008"/>
+          </a:xfrm>
+          <a:prstGeom prst="rect">
+            <a:avLst/>
+          </a:prstGeom>
+          <a:solidFill>
+            <a:srgbClr val="16C7E8"/>
+          </a:solidFill>
+          <a:ln/>
+        </p:spPr>
+      </p:sp>
+    </p:spTree>
+  </p:cSld>
+  <p:clrMapOvr>
+    <a:masterClrMapping/>
+  </p:clrMapOvr>
+</p:sld>
+</file>
+
+<file path=ppt/slides/slide11.xml><?xml version="1.0" encoding="utf-8"?>
+<p:sld xmlns:a="http://schemas.openxmlformats.org/drawingml/2006/main" xmlns:r="http://schemas.openxmlformats.org/officeDocument/2006/relationships" xmlns:p="http://schemas.openxmlformats.org/presentationml/2006/main">
+  <p:cSld name="Slide 5">
+    <p:bg>
+      <p:bgPr>
+        <a:solidFill>
+          <a:srgbClr val="F3FAFD"/>
+        </a:solidFill>
+      </p:bgPr>
+    </p:bg>
+    <p:spTree>
+      <p:nvGrpSpPr>
+        <p:cNvPr id="1" name=""/>
+        <p:cNvGrpSpPr/>
+        <p:nvPr/>
+      </p:nvGrpSpPr>
+      <p:grpSpPr>
+        <a:xfrm>
+          <a:off x="0" y="0"/>
+          <a:ext cx="0" cy="0"/>
+          <a:chOff x="0" y="0"/>
+          <a:chExt cx="0" cy="0"/>
+        </a:xfrm>
+      </p:grpSpPr>
+      <p:sp>
+        <p:nvSpPr>
+          <p:cNvPr id="2" name="Shape 0"/>
+          <p:cNvSpPr/>
+          <p:nvPr/>
+        </p:nvSpPr>
+        <p:spPr>
+          <a:xfrm>
+            <a:off x="621792" y="438912"/>
+            <a:ext cx="2176272" cy="310896"/>
+          </a:xfrm>
+          <a:prstGeom prst="roundRect">
+            <a:avLst>
+              <a:gd name="adj" fmla="val 23529"/>
+            </a:avLst>
+          </a:prstGeom>
+          <a:solidFill>
+            <a:srgbClr val="11162B"/>
+          </a:solidFill>
+          <a:ln/>
+        </p:spPr>
+      </p:sp>
+      <p:sp>
+        <p:nvSpPr>
+          <p:cNvPr id="3" name="Text 1"/>
+          <p:cNvSpPr/>
+          <p:nvPr/>
+        </p:nvSpPr>
+        <p:spPr>
+          <a:xfrm>
+            <a:off x="768096" y="530352"/>
+            <a:ext cx="1874520" cy="109728"/>
+          </a:xfrm>
+          <a:prstGeom prst="rect">
+            <a:avLst/>
+          </a:prstGeom>
+          <a:noFill/>
+          <a:ln/>
+        </p:spPr>
+        <p:txBody>
+          <a:bodyPr wrap="square" lIns="0" tIns="0" rIns="0" bIns="0" rtlCol="0" anchor="ctr">
+            <a:normAutofit/>
+          </a:bodyPr>
+          <a:lstStyle/>
+          <a:p>
+            <a:pPr indent="0" marL="0">
+              <a:buNone/>
+            </a:pPr>
+            <a:r>
+              <a:rPr lang="en-US" sz="820" b="1" spc="120" kern="0" dirty="0">
+                <a:solidFill>
+                  <a:srgbClr val="FFFFFF"/>
+                </a:solidFill>
+                <a:latin typeface="Aptos" pitchFamily="34" charset="0"/>
+                <a:ea typeface="Aptos" pitchFamily="34" charset="-122"/>
+                <a:cs typeface="Aptos" pitchFamily="34" charset="-120"/>
+              </a:rPr>
+              <a:t>DAY 5  /  MODULE 1  /  SIGNAL PATH</a:t>
+            </a:r>
+            <a:endParaRPr lang="en-US" sz="820" dirty="0"/>
+          </a:p>
+        </p:txBody>
+      </p:sp>
+      <p:sp>
+        <p:nvSpPr>
+          <p:cNvPr id="4" name="Text 2"/>
+          <p:cNvSpPr/>
+          <p:nvPr/>
+        </p:nvSpPr>
+        <p:spPr>
+          <a:xfrm>
+            <a:off x="640080" y="841248"/>
+            <a:ext cx="10012680" cy="475488"/>
+          </a:xfrm>
+          <a:prstGeom prst="rect">
+            <a:avLst/>
+          </a:prstGeom>
+          <a:noFill/>
+          <a:ln/>
+        </p:spPr>
+        <p:txBody>
+          <a:bodyPr wrap="square" lIns="0" tIns="0" rIns="0" bIns="0" rtlCol="0" anchor="ctr">
+            <a:normAutofit/>
+          </a:bodyPr>
+          <a:lstStyle/>
+          <a:p>
+            <a:pPr indent="0" marL="0">
+              <a:buNone/>
+            </a:pPr>
+            <a:r>
+              <a:rPr lang="en-US" sz="3100" b="1" dirty="0">
+                <a:solidFill>
+                  <a:srgbClr val="11162B"/>
+                </a:solidFill>
+                <a:latin typeface="Aptos Display" pitchFamily="34" charset="0"/>
+                <a:ea typeface="Aptos Display" pitchFamily="34" charset="-122"/>
+                <a:cs typeface="Aptos Display" pitchFamily="34" charset="-120"/>
+              </a:rPr>
+              <a:t>Server-side and client-side traces</a:t>
+            </a:r>
+            <a:endParaRPr lang="en-US" sz="3100" dirty="0"/>
+          </a:p>
+        </p:txBody>
+      </p:sp>
+      <p:sp>
+        <p:nvSpPr>
+          <p:cNvPr id="5" name="Shape 3"/>
+          <p:cNvSpPr/>
+          <p:nvPr/>
+        </p:nvSpPr>
+        <p:spPr>
+          <a:xfrm>
+            <a:off x="10857220" y="548640"/>
+            <a:ext cx="164592" cy="197510"/>
+          </a:xfrm>
+          <a:prstGeom prst="line">
+            <a:avLst/>
+          </a:prstGeom>
+          <a:noFill/>
+          <a:ln w="25400">
+            <a:solidFill>
+              <a:srgbClr val="11162B"/>
+            </a:solidFill>
+            <a:prstDash val="solid"/>
+          </a:ln>
+        </p:spPr>
+      </p:sp>
+      <p:sp>
+        <p:nvSpPr>
+          <p:cNvPr id="6" name="Shape 4"/>
+          <p:cNvSpPr/>
+          <p:nvPr/>
+        </p:nvSpPr>
+        <p:spPr>
+          <a:xfrm>
+            <a:off x="11034979" y="542056"/>
+            <a:ext cx="158008" cy="164592"/>
+          </a:xfrm>
+          <a:prstGeom prst="line">
+            <a:avLst/>
+          </a:prstGeom>
+          <a:noFill/>
+          <a:ln w="25400">
+            <a:solidFill>
+              <a:srgbClr val="11162B"/>
+            </a:solidFill>
+            <a:prstDash val="solid"/>
+          </a:ln>
+        </p:spPr>
+      </p:sp>
+      <p:sp>
+        <p:nvSpPr>
+          <p:cNvPr id="7" name="Shape 5"/>
+          <p:cNvSpPr/>
+          <p:nvPr/>
+        </p:nvSpPr>
+        <p:spPr>
+          <a:xfrm>
+            <a:off x="11199571" y="502554"/>
+            <a:ext cx="158008" cy="197510"/>
+          </a:xfrm>
+          <a:prstGeom prst="line">
+            <a:avLst/>
+          </a:prstGeom>
+          <a:noFill/>
+          <a:ln w="25400">
+            <a:solidFill>
+              <a:srgbClr val="11162B"/>
+            </a:solidFill>
+            <a:prstDash val="solid"/>
+          </a:ln>
+        </p:spPr>
+      </p:sp>
+      <p:sp>
+        <p:nvSpPr>
+          <p:cNvPr id="8" name="Shape 6"/>
+          <p:cNvSpPr/>
+          <p:nvPr/>
+        </p:nvSpPr>
+        <p:spPr>
+          <a:xfrm>
+            <a:off x="11199571" y="713232"/>
+            <a:ext cx="158008" cy="184343"/>
+          </a:xfrm>
+          <a:prstGeom prst="line">
+            <a:avLst/>
+          </a:prstGeom>
+          <a:noFill/>
+          <a:ln w="25400">
+            <a:solidFill>
+              <a:srgbClr val="11162B"/>
+            </a:solidFill>
+            <a:prstDash val="dash"/>
+          </a:ln>
+        </p:spPr>
+      </p:sp>
+      <p:sp>
+        <p:nvSpPr>
+          <p:cNvPr id="9" name="Shape 7"/>
+          <p:cNvSpPr/>
+          <p:nvPr/>
+        </p:nvSpPr>
+        <p:spPr>
+          <a:xfrm>
+            <a:off x="10824301" y="726399"/>
+            <a:ext cx="98755" cy="98755"/>
+          </a:xfrm>
+          <a:prstGeom prst="ellipse">
+            <a:avLst/>
+          </a:prstGeom>
+          <a:solidFill>
+            <a:srgbClr val="E4F7FB"/>
+          </a:solidFill>
+          <a:ln w="10160">
+            <a:solidFill>
+              <a:srgbClr val="11162B"/>
+            </a:solidFill>
+            <a:prstDash val="solid"/>
+          </a:ln>
+        </p:spPr>
+      </p:sp>
+      <p:sp>
+        <p:nvSpPr>
+          <p:cNvPr id="10" name="Shape 8"/>
+          <p:cNvSpPr/>
+          <p:nvPr/>
+        </p:nvSpPr>
+        <p:spPr>
+          <a:xfrm>
+            <a:off x="11008644" y="502554"/>
+            <a:ext cx="98755" cy="98755"/>
+          </a:xfrm>
+          <a:prstGeom prst="ellipse">
+            <a:avLst/>
+          </a:prstGeom>
+          <a:solidFill>
+            <a:srgbClr val="E4F7FB"/>
+          </a:solidFill>
+          <a:ln w="10160">
+            <a:solidFill>
+              <a:srgbClr val="11162B"/>
+            </a:solidFill>
+            <a:prstDash val="solid"/>
+          </a:ln>
+        </p:spPr>
+      </p:sp>
+      <p:sp>
+        <p:nvSpPr>
+          <p:cNvPr id="11" name="Shape 9"/>
+          <p:cNvSpPr/>
+          <p:nvPr/>
+        </p:nvSpPr>
+        <p:spPr>
+          <a:xfrm>
+            <a:off x="11179820" y="700065"/>
+            <a:ext cx="98755" cy="98755"/>
+          </a:xfrm>
+          <a:prstGeom prst="ellipse">
+            <a:avLst/>
+          </a:prstGeom>
+          <a:solidFill>
+            <a:srgbClr val="16C7E8"/>
+          </a:solidFill>
+          <a:ln w="10160">
+            <a:solidFill>
+              <a:srgbClr val="11162B"/>
+            </a:solidFill>
+            <a:prstDash val="solid"/>
+          </a:ln>
+        </p:spPr>
+      </p:sp>
+      <p:sp>
+        <p:nvSpPr>
+          <p:cNvPr id="12" name="Shape 10"/>
+          <p:cNvSpPr/>
+          <p:nvPr/>
+        </p:nvSpPr>
+        <p:spPr>
+          <a:xfrm>
+            <a:off x="11350996" y="463052"/>
+            <a:ext cx="98755" cy="98755"/>
+          </a:xfrm>
+          <a:prstGeom prst="ellipse">
+            <a:avLst/>
+          </a:prstGeom>
+          <a:solidFill>
+            <a:srgbClr val="E4F7FB"/>
+          </a:solidFill>
+          <a:ln w="10160">
+            <a:solidFill>
+              <a:srgbClr val="11162B"/>
+            </a:solidFill>
+            <a:prstDash val="solid"/>
+          </a:ln>
+        </p:spPr>
+      </p:sp>
+      <p:sp>
+        <p:nvSpPr>
+          <p:cNvPr id="13" name="Shape 11"/>
+          <p:cNvSpPr/>
+          <p:nvPr/>
+        </p:nvSpPr>
+        <p:spPr>
+          <a:xfrm>
+            <a:off x="11377331" y="923910"/>
+            <a:ext cx="98755" cy="98755"/>
+          </a:xfrm>
+          <a:prstGeom prst="ellipse">
+            <a:avLst/>
+          </a:prstGeom>
+          <a:solidFill>
+            <a:srgbClr val="E4F7FB"/>
+          </a:solidFill>
+          <a:ln w="10160">
+            <a:solidFill>
+              <a:srgbClr val="11162B"/>
+            </a:solidFill>
+            <a:prstDash val="solid"/>
+          </a:ln>
+        </p:spPr>
+      </p:sp>
+      <p:sp>
+        <p:nvSpPr>
+          <p:cNvPr id="14" name="Shape 12"/>
+          <p:cNvSpPr/>
+          <p:nvPr/>
+        </p:nvSpPr>
+        <p:spPr>
+          <a:xfrm>
+            <a:off x="11612880" y="457200"/>
+            <a:ext cx="329184" cy="329184"/>
+          </a:xfrm>
+          <a:prstGeom prst="ellipse">
+            <a:avLst/>
+          </a:prstGeom>
+          <a:solidFill>
+            <a:srgbClr val="16C7E8"/>
+          </a:solidFill>
+          <a:ln/>
+        </p:spPr>
+      </p:sp>
+      <p:sp>
+        <p:nvSpPr>
+          <p:cNvPr id="15" name="Text 13"/>
+          <p:cNvSpPr/>
+          <p:nvPr/>
+        </p:nvSpPr>
+        <p:spPr>
+          <a:xfrm>
+            <a:off x="11612880" y="553212"/>
+            <a:ext cx="329184" cy="100584"/>
+          </a:xfrm>
+          <a:prstGeom prst="rect">
+            <a:avLst/>
+          </a:prstGeom>
+          <a:noFill/>
+          <a:ln/>
+        </p:spPr>
+        <p:txBody>
+          <a:bodyPr wrap="square" lIns="0" tIns="0" rIns="0" bIns="0" rtlCol="0" anchor="ctr"/>
+          <a:lstStyle/>
+          <a:p>
+            <a:pPr algn="ctr" indent="0" marL="0">
+              <a:buNone/>
+            </a:pPr>
+            <a:r>
+              <a:rPr lang="en-US" sz="850" b="1" dirty="0">
+                <a:solidFill>
+                  <a:srgbClr val="11162B"/>
+                </a:solidFill>
+                <a:latin typeface="Aptos" pitchFamily="34" charset="0"/>
+                <a:ea typeface="Aptos" pitchFamily="34" charset="-122"/>
+                <a:cs typeface="Aptos" pitchFamily="34" charset="-120"/>
+              </a:rPr>
+              <a:t>06</a:t>
+            </a:r>
+            <a:endParaRPr lang="en-US" sz="850" dirty="0"/>
+          </a:p>
+        </p:txBody>
+      </p:sp>
+      <p:sp>
+        <p:nvSpPr>
+          <p:cNvPr id="16" name="Shape 14"/>
+          <p:cNvSpPr/>
+          <p:nvPr/>
+        </p:nvSpPr>
+        <p:spPr>
+          <a:xfrm>
+            <a:off x="9829800" y="1005840"/>
+            <a:ext cx="2148840" cy="2148840"/>
+          </a:xfrm>
+          <a:prstGeom prst="ellipse">
+            <a:avLst/>
+          </a:prstGeom>
+          <a:solidFill>
+            <a:srgbClr val="E4F7FB"/>
+          </a:solidFill>
+          <a:ln/>
+        </p:spPr>
+      </p:sp>
+      <p:sp>
+        <p:nvSpPr>
+          <p:cNvPr id="17" name="Shape 15"/>
+          <p:cNvSpPr/>
+          <p:nvPr/>
+        </p:nvSpPr>
+        <p:spPr>
+          <a:xfrm>
+            <a:off x="640080" y="1417320"/>
+            <a:ext cx="5623560" cy="4645152"/>
+          </a:xfrm>
+          <a:prstGeom prst="roundRect">
+            <a:avLst>
+              <a:gd name="adj" fmla="val 1575"/>
+            </a:avLst>
+          </a:prstGeom>
+          <a:solidFill>
+            <a:srgbClr val="FFFFFF"/>
+          </a:solidFill>
+          <a:ln w="10160">
+            <a:solidFill>
+              <a:srgbClr val="E4F7FB"/>
+            </a:solidFill>
+            <a:prstDash val="solid"/>
+          </a:ln>
+        </p:spPr>
+      </p:sp>
+      <p:sp>
+        <p:nvSpPr>
+          <p:cNvPr id="18" name="Text 16"/>
+          <p:cNvSpPr/>
+          <p:nvPr/>
+        </p:nvSpPr>
+        <p:spPr>
+          <a:xfrm>
+            <a:off x="941832" y="1737360"/>
+            <a:ext cx="3017520" cy="164592"/>
+          </a:xfrm>
+          <a:prstGeom prst="rect">
+            <a:avLst/>
+          </a:prstGeom>
+          <a:noFill/>
+          <a:ln/>
+        </p:spPr>
+        <p:txBody>
+          <a:bodyPr wrap="square" lIns="0" tIns="0" rIns="0" bIns="0" rtlCol="0" anchor="ctr"/>
+          <a:lstStyle/>
+          <a:p>
+            <a:pPr indent="0" marL="0">
+              <a:buNone/>
+            </a:pPr>
+            <a:r>
+              <a:rPr lang="en-US" sz="1000" b="1" spc="210" kern="0" dirty="0">
+                <a:solidFill>
+                  <a:srgbClr val="8B5CF6"/>
+                </a:solidFill>
+                <a:latin typeface="Aptos" pitchFamily="34" charset="0"/>
+                <a:ea typeface="Aptos" pitchFamily="34" charset="-122"/>
+                <a:cs typeface="Aptos" pitchFamily="34" charset="-120"/>
+              </a:rPr>
+              <a:t>SERVER-SIDE — START HERE</a:t>
+            </a:r>
+            <a:endParaRPr lang="en-US" sz="1000" dirty="0"/>
+          </a:p>
+        </p:txBody>
+      </p:sp>
+      <p:sp>
+        <p:nvSpPr>
+          <p:cNvPr id="19" name="Shape 17"/>
+          <p:cNvSpPr/>
+          <p:nvPr/>
+        </p:nvSpPr>
+        <p:spPr>
+          <a:xfrm>
+            <a:off x="987552" y="2103120"/>
+            <a:ext cx="1444752" cy="713232"/>
+          </a:xfrm>
+          <a:prstGeom prst="roundRect">
+            <a:avLst>
+              <a:gd name="adj" fmla="val 10256"/>
+            </a:avLst>
+          </a:prstGeom>
+          <a:solidFill>
+            <a:srgbClr val="11162B"/>
+          </a:solidFill>
+          <a:ln/>
+        </p:spPr>
+      </p:sp>
+      <p:sp>
+        <p:nvSpPr>
+          <p:cNvPr id="20" name="Text 18"/>
+          <p:cNvSpPr/>
+          <p:nvPr/>
+        </p:nvSpPr>
+        <p:spPr>
+          <a:xfrm>
+            <a:off x="1170432" y="2286000"/>
+            <a:ext cx="1078992" cy="310896"/>
+          </a:xfrm>
+          <a:prstGeom prst="rect">
+            <a:avLst/>
+          </a:prstGeom>
+          <a:noFill/>
+          <a:ln/>
+        </p:spPr>
+        <p:txBody>
+          <a:bodyPr wrap="square" lIns="0" tIns="0" rIns="0" bIns="0" rtlCol="0" anchor="ctr"/>
+          <a:lstStyle/>
+          <a:p>
+            <a:pPr algn="ctr" indent="0" marL="0">
+              <a:buNone/>
+            </a:pPr>
+            <a:r>
+              <a:rPr lang="en-US" sz="1150" b="1" dirty="0">
+                <a:solidFill>
+                  <a:srgbClr val="FFFFFF"/>
+                </a:solidFill>
+                <a:latin typeface="Aptos" pitchFamily="34" charset="0"/>
+                <a:ea typeface="Aptos" pitchFamily="34" charset="-122"/>
+                <a:cs typeface="Aptos" pitchFamily="34" charset="-120"/>
+              </a:rPr>
+              <a:t>FOUNDRY</a:t>
+            </a:r>
+            <a:endParaRPr lang="en-US" sz="1150" dirty="0"/>
+          </a:p>
+          <a:p>
+            <a:pPr algn="ctr" indent="0" marL="0">
+              <a:buNone/>
+            </a:pPr>
+            <a:r>
+              <a:rPr lang="en-US" sz="1150" b="1" dirty="0">
+                <a:solidFill>
+                  <a:srgbClr val="FFFFFF"/>
+                </a:solidFill>
+                <a:latin typeface="Aptos" pitchFamily="34" charset="0"/>
+                <a:ea typeface="Aptos" pitchFamily="34" charset="-122"/>
+                <a:cs typeface="Aptos" pitchFamily="34" charset="-120"/>
+              </a:rPr>
+              <a:t>HOSTED AGENT</a:t>
+            </a:r>
+            <a:endParaRPr lang="en-US" sz="1150" dirty="0"/>
+          </a:p>
+        </p:txBody>
+      </p:sp>
+      <p:sp>
+        <p:nvSpPr>
+          <p:cNvPr id="21" name="Shape 19"/>
+          <p:cNvSpPr/>
+          <p:nvPr/>
+        </p:nvSpPr>
+        <p:spPr>
+          <a:xfrm>
+            <a:off x="2724912" y="2139696"/>
+            <a:ext cx="1353312" cy="640080"/>
+          </a:xfrm>
+          <a:prstGeom prst="roundRect">
+            <a:avLst>
+              <a:gd name="adj" fmla="val 11429"/>
+            </a:avLst>
+          </a:prstGeom>
+          <a:solidFill>
+            <a:srgbClr val="E4F7FB"/>
+          </a:solidFill>
+          <a:ln/>
+        </p:spPr>
+      </p:sp>
+      <p:sp>
+        <p:nvSpPr>
+          <p:cNvPr id="22" name="Text 20"/>
+          <p:cNvSpPr/>
+          <p:nvPr/>
+        </p:nvSpPr>
+        <p:spPr>
+          <a:xfrm>
+            <a:off x="2862072" y="2359152"/>
+            <a:ext cx="1078992" cy="128016"/>
+          </a:xfrm>
+          <a:prstGeom prst="rect">
+            <a:avLst/>
+          </a:prstGeom>
+          <a:noFill/>
+          <a:ln/>
+        </p:spPr>
+        <p:txBody>
+          <a:bodyPr wrap="square" lIns="0" tIns="0" rIns="0" bIns="0" rtlCol="0" anchor="ctr"/>
+          <a:lstStyle/>
+          <a:p>
+            <a:pPr algn="ctr" indent="0" marL="0">
+              <a:buNone/>
+            </a:pPr>
+            <a:r>
+              <a:rPr lang="en-US" sz="950" b="1" dirty="0">
+                <a:solidFill>
+                  <a:srgbClr val="11162B"/>
+                </a:solidFill>
+                <a:latin typeface="Consolas" pitchFamily="34" charset="0"/>
+                <a:ea typeface="Consolas" pitchFamily="34" charset="-122"/>
+                <a:cs typeface="Consolas" pitchFamily="34" charset="-120"/>
+              </a:rPr>
+              <a:t>AUTOMATIC TRACE</a:t>
+            </a:r>
+            <a:endParaRPr lang="en-US" sz="950" dirty="0"/>
+          </a:p>
+        </p:txBody>
+      </p:sp>
+      <p:sp>
+        <p:nvSpPr>
+          <p:cNvPr id="23" name="Shape 21"/>
+          <p:cNvSpPr/>
+          <p:nvPr/>
+        </p:nvSpPr>
+        <p:spPr>
+          <a:xfrm>
+            <a:off x="2432304" y="2450592"/>
+            <a:ext cx="292608" cy="0"/>
+          </a:xfrm>
+          <a:prstGeom prst="line">
+            <a:avLst/>
+          </a:prstGeom>
+          <a:noFill/>
+          <a:ln w="25400">
+            <a:solidFill>
+              <a:srgbClr val="11162B"/>
+            </a:solidFill>
+            <a:prstDash val="solid"/>
+          </a:ln>
+        </p:spPr>
+      </p:sp>
+      <p:sp>
+        <p:nvSpPr>
+          <p:cNvPr id="24" name="Shape 22"/>
+          <p:cNvSpPr/>
+          <p:nvPr/>
+        </p:nvSpPr>
+        <p:spPr>
+          <a:xfrm>
+            <a:off x="4370832" y="2103120"/>
+            <a:ext cx="1444752" cy="713232"/>
+          </a:xfrm>
+          <a:prstGeom prst="roundRect">
+            <a:avLst>
+              <a:gd name="adj" fmla="val 10256"/>
+            </a:avLst>
+          </a:prstGeom>
+          <a:solidFill>
+            <a:srgbClr val="EEE9FF"/>
+          </a:solidFill>
+          <a:ln/>
+        </p:spPr>
+      </p:sp>
+      <p:sp>
+        <p:nvSpPr>
+          <p:cNvPr id="25" name="Text 23"/>
+          <p:cNvSpPr/>
+          <p:nvPr/>
+        </p:nvSpPr>
+        <p:spPr>
+          <a:xfrm>
+            <a:off x="4553712" y="2276856"/>
+            <a:ext cx="1078992" cy="310896"/>
+          </a:xfrm>
+          <a:prstGeom prst="rect">
+            <a:avLst/>
+          </a:prstGeom>
+          <a:noFill/>
+          <a:ln/>
+        </p:spPr>
+        <p:txBody>
+          <a:bodyPr wrap="square" lIns="0" tIns="0" rIns="0" bIns="0" rtlCol="0" anchor="ctr"/>
+          <a:lstStyle/>
+          <a:p>
+            <a:pPr algn="ctr" indent="0" marL="0">
+              <a:buNone/>
+            </a:pPr>
+            <a:r>
+              <a:rPr lang="en-US" sz="1100" b="1" dirty="0">
+                <a:solidFill>
+                  <a:srgbClr val="11162B"/>
+                </a:solidFill>
+                <a:latin typeface="Aptos" pitchFamily="34" charset="0"/>
+                <a:ea typeface="Aptos" pitchFamily="34" charset="-122"/>
+                <a:cs typeface="Aptos" pitchFamily="34" charset="-120"/>
+              </a:rPr>
+              <a:t>APPLICATION</a:t>
+            </a:r>
+            <a:endParaRPr lang="en-US" sz="1100" dirty="0"/>
+          </a:p>
+          <a:p>
+            <a:pPr algn="ctr" indent="0" marL="0">
+              <a:buNone/>
+            </a:pPr>
+            <a:r>
+              <a:rPr lang="en-US" sz="1100" b="1" dirty="0">
+                <a:solidFill>
+                  <a:srgbClr val="11162B"/>
+                </a:solidFill>
+                <a:latin typeface="Aptos" pitchFamily="34" charset="0"/>
+                <a:ea typeface="Aptos" pitchFamily="34" charset="-122"/>
+                <a:cs typeface="Aptos" pitchFamily="34" charset="-120"/>
+              </a:rPr>
+              <a:t>INSIGHTS</a:t>
+            </a:r>
+            <a:endParaRPr lang="en-US" sz="1100" dirty="0"/>
+          </a:p>
+        </p:txBody>
+      </p:sp>
+      <p:sp>
+        <p:nvSpPr>
+          <p:cNvPr id="26" name="Shape 24"/>
+          <p:cNvSpPr/>
+          <p:nvPr/>
+        </p:nvSpPr>
+        <p:spPr>
+          <a:xfrm>
+            <a:off x="4078224" y="2450592"/>
+            <a:ext cx="292608" cy="0"/>
+          </a:xfrm>
+          <a:prstGeom prst="line">
+            <a:avLst/>
+          </a:prstGeom>
+          <a:noFill/>
+          <a:ln w="25400">
+            <a:solidFill>
+              <a:srgbClr val="8B5CF6"/>
+            </a:solidFill>
+            <a:prstDash val="dash"/>
+          </a:ln>
+        </p:spPr>
+      </p:sp>
+      <p:sp>
+        <p:nvSpPr>
+          <p:cNvPr id="27" name="Text 25"/>
+          <p:cNvSpPr/>
+          <p:nvPr/>
+        </p:nvSpPr>
+        <p:spPr>
+          <a:xfrm>
+            <a:off x="4005072" y="2194560"/>
+            <a:ext cx="438912" cy="109728"/>
+          </a:xfrm>
+          <a:prstGeom prst="rect">
+            <a:avLst/>
+          </a:prstGeom>
+          <a:noFill/>
+          <a:ln/>
+        </p:spPr>
+        <p:txBody>
+          <a:bodyPr wrap="square" lIns="0" tIns="0" rIns="0" bIns="0" rtlCol="0" anchor="ctr"/>
+          <a:lstStyle/>
+          <a:p>
+            <a:pPr algn="ctr" indent="0" marL="0">
+              <a:buNone/>
+            </a:pPr>
+            <a:r>
+              <a:rPr lang="en-US" sz="800" b="1" dirty="0">
+                <a:solidFill>
+                  <a:srgbClr val="8B5CF6"/>
+                </a:solidFill>
+                <a:latin typeface="Aptos" pitchFamily="34" charset="0"/>
+                <a:ea typeface="Aptos" pitchFamily="34" charset="-122"/>
+                <a:cs typeface="Aptos" pitchFamily="34" charset="-120"/>
+              </a:rPr>
+              <a:t>LINK</a:t>
+            </a:r>
+            <a:endParaRPr lang="en-US" sz="800" dirty="0"/>
+          </a:p>
+        </p:txBody>
+      </p:sp>
+      <p:sp>
+        <p:nvSpPr>
+          <p:cNvPr id="28" name="Text 26"/>
+          <p:cNvSpPr/>
+          <p:nvPr/>
+        </p:nvSpPr>
+        <p:spPr>
+          <a:xfrm>
+            <a:off x="950976" y="3154680"/>
+            <a:ext cx="4983480" cy="2240280"/>
+          </a:xfrm>
+          <a:prstGeom prst="rect">
+            <a:avLst/>
+          </a:prstGeom>
+          <a:noFill/>
+          <a:ln/>
+        </p:spPr>
+        <p:txBody>
+          <a:bodyPr wrap="square" lIns="0" tIns="0" rIns="0" bIns="0" rtlCol="0" anchor="t">
+            <a:normAutofit/>
+          </a:bodyPr>
+          <a:lstStyle/>
+          <a:p>
+            <a:pPr marL="342900" indent="-342900">
+              <a:buSzPct val="100000"/>
+              <a:buChar char="•"/>
+            </a:pPr>
+            <a:r>
+              <a:rPr lang="en-US" sz="1300" dirty="0">
+                <a:solidFill>
+                  <a:srgbClr val="151B31"/>
+                </a:solidFill>
+                <a:latin typeface="Aptos" pitchFamily="34" charset="0"/>
+                <a:ea typeface="Aptos" pitchFamily="34" charset="-122"/>
+                <a:cs typeface="Aptos" pitchFamily="34" charset="-120"/>
+              </a:rPr>
+              <a:t>Foundry enables tracing after Application Insights is connected to the project</a:t>
+            </a:r>
+            <a:endParaRPr lang="en-US" sz="1300" dirty="0"/>
+          </a:p>
+          <a:p>
+            <a:pPr marL="342900" indent="-342900">
+              <a:buSzPct val="100000"/>
+              <a:buChar char="•"/>
+            </a:pPr>
+            <a:r>
+              <a:rPr lang="en-US" sz="1300" dirty="0">
+                <a:solidFill>
+                  <a:srgbClr val="151B31"/>
+                </a:solidFill>
+                <a:latin typeface="Aptos" pitchFamily="34" charset="0"/>
+                <a:ea typeface="Aptos" pitchFamily="34" charset="-122"/>
+                <a:cs typeface="Aptos" pitchFamily="34" charset="-120"/>
+              </a:rPr>
+              <a:t>No application code changes are required for supported agents hosted in Foundry</a:t>
+            </a:r>
+            <a:endParaRPr lang="en-US" sz="1300" dirty="0"/>
+          </a:p>
+          <a:p>
+            <a:pPr marL="342900" indent="-342900">
+              <a:buSzPct val="100000"/>
+              <a:buChar char="•"/>
+            </a:pPr>
+            <a:r>
+              <a:rPr lang="en-US" sz="1300" dirty="0">
+                <a:solidFill>
+                  <a:srgbClr val="151B31"/>
+                </a:solidFill>
+                <a:latin typeface="Aptos" pitchFamily="34" charset="0"/>
+                <a:ea typeface="Aptos" pitchFamily="34" charset="-122"/>
+                <a:cs typeface="Aptos" pitchFamily="34" charset="-120"/>
+              </a:rPr>
+              <a:t>Use these traces to inspect activity inside the Foundry-hosted boundary</a:t>
+            </a:r>
+            <a:endParaRPr lang="en-US" sz="1300" dirty="0"/>
+          </a:p>
+        </p:txBody>
+      </p:sp>
+      <p:sp>
+        <p:nvSpPr>
+          <p:cNvPr id="29" name="Shape 27"/>
+          <p:cNvSpPr/>
+          <p:nvPr/>
+        </p:nvSpPr>
+        <p:spPr>
+          <a:xfrm>
+            <a:off x="6492240" y="1417320"/>
+            <a:ext cx="5056632" cy="4645152"/>
+          </a:xfrm>
+          <a:prstGeom prst="roundRect">
+            <a:avLst>
+              <a:gd name="adj" fmla="val 1575"/>
+            </a:avLst>
+          </a:prstGeom>
+          <a:solidFill>
+            <a:srgbClr val="E4F7FB"/>
+          </a:solidFill>
+          <a:ln w="10160">
+            <a:solidFill>
+              <a:srgbClr val="16C7E8"/>
+            </a:solidFill>
+            <a:prstDash val="solid"/>
+          </a:ln>
+        </p:spPr>
+      </p:sp>
+      <p:sp>
+        <p:nvSpPr>
+          <p:cNvPr id="30" name="Text 28"/>
+          <p:cNvSpPr/>
+          <p:nvPr/>
+        </p:nvSpPr>
+        <p:spPr>
+          <a:xfrm>
+            <a:off x="6793992" y="1737360"/>
+            <a:ext cx="3017520" cy="164592"/>
+          </a:xfrm>
+          <a:prstGeom prst="rect">
+            <a:avLst/>
+          </a:prstGeom>
+          <a:noFill/>
+          <a:ln/>
+        </p:spPr>
+        <p:txBody>
+          <a:bodyPr wrap="square" lIns="0" tIns="0" rIns="0" bIns="0" rtlCol="0" anchor="ctr"/>
+          <a:lstStyle/>
+          <a:p>
+            <a:pPr indent="0" marL="0">
+              <a:buNone/>
+            </a:pPr>
+            <a:r>
+              <a:rPr lang="en-US" sz="1000" b="1" spc="210" kern="0" dirty="0">
+                <a:solidFill>
+                  <a:srgbClr val="8B5CF6"/>
+                </a:solidFill>
+                <a:latin typeface="Aptos" pitchFamily="34" charset="0"/>
+                <a:ea typeface="Aptos" pitchFamily="34" charset="-122"/>
+                <a:cs typeface="Aptos" pitchFamily="34" charset="-120"/>
+              </a:rPr>
+              <a:t>CLIENT-SIDE — EXTEND THE VIEW</a:t>
+            </a:r>
+            <a:endParaRPr lang="en-US" sz="1000" dirty="0"/>
+          </a:p>
+        </p:txBody>
+      </p:sp>
+      <p:sp>
+        <p:nvSpPr>
+          <p:cNvPr id="31" name="Shape 29"/>
+          <p:cNvSpPr/>
+          <p:nvPr/>
+        </p:nvSpPr>
+        <p:spPr>
+          <a:xfrm>
+            <a:off x="6821424" y="2340864"/>
+            <a:ext cx="438912" cy="438912"/>
+          </a:xfrm>
+          <a:prstGeom prst="ellipse">
+            <a:avLst/>
+          </a:prstGeom>
+          <a:solidFill>
+            <a:srgbClr val="16C7E8"/>
+          </a:solidFill>
+          <a:ln/>
+        </p:spPr>
+      </p:sp>
+      <p:sp>
+        <p:nvSpPr>
+          <p:cNvPr id="32" name="Text 30"/>
+          <p:cNvSpPr/>
+          <p:nvPr/>
+        </p:nvSpPr>
+        <p:spPr>
+          <a:xfrm>
+            <a:off x="6821424" y="2478024"/>
+            <a:ext cx="438912" cy="109728"/>
+          </a:xfrm>
+          <a:prstGeom prst="rect">
+            <a:avLst/>
+          </a:prstGeom>
+          <a:noFill/>
+          <a:ln/>
+        </p:spPr>
+        <p:txBody>
+          <a:bodyPr wrap="square" lIns="0" tIns="0" rIns="0" bIns="0" rtlCol="0" anchor="ctr"/>
+          <a:lstStyle/>
+          <a:p>
+            <a:pPr algn="ctr" indent="0" marL="0">
+              <a:buNone/>
+            </a:pPr>
+            <a:r>
+              <a:rPr lang="en-US" sz="900" b="1" dirty="0">
+                <a:solidFill>
+                  <a:srgbClr val="11162B"/>
+                </a:solidFill>
+                <a:latin typeface="Aptos" pitchFamily="34" charset="0"/>
+                <a:ea typeface="Aptos" pitchFamily="34" charset="-122"/>
+                <a:cs typeface="Aptos" pitchFamily="34" charset="-120"/>
+              </a:rPr>
+              <a:t>1</a:t>
+            </a:r>
+            <a:endParaRPr lang="en-US" sz="900" dirty="0"/>
+          </a:p>
+        </p:txBody>
+      </p:sp>
+      <p:sp>
+        <p:nvSpPr>
+          <p:cNvPr id="33" name="Text 31"/>
+          <p:cNvSpPr/>
+          <p:nvPr/>
+        </p:nvSpPr>
+        <p:spPr>
+          <a:xfrm>
+            <a:off x="7498080" y="2176272"/>
+            <a:ext cx="3886200" cy="749808"/>
+          </a:xfrm>
+          <a:prstGeom prst="rect">
+            <a:avLst/>
+          </a:prstGeom>
+          <a:noFill/>
+          <a:ln/>
+        </p:spPr>
+        <p:txBody>
+          <a:bodyPr wrap="square" lIns="0" tIns="0" rIns="0" bIns="0" rtlCol="0" anchor="ctr">
+            <a:normAutofit/>
+          </a:bodyPr>
+          <a:lstStyle/>
+          <a:p>
+            <a:pPr indent="0" marL="0">
+              <a:buNone/>
+            </a:pPr>
+            <a:r>
+              <a:rPr lang="en-US" sz="1450" dirty="0">
+                <a:solidFill>
+                  <a:srgbClr val="151B31"/>
+                </a:solidFill>
+                <a:latin typeface="Aptos" pitchFamily="34" charset="0"/>
+                <a:ea typeface="Aptos" pitchFamily="34" charset="-122"/>
+                <a:cs typeface="Aptos" pitchFamily="34" charset="-120"/>
+              </a:rPr>
+              <a:t>Instrument application-owned logic around the agent call</a:t>
+            </a:r>
+            <a:endParaRPr lang="en-US" sz="1450" dirty="0"/>
+          </a:p>
+        </p:txBody>
+      </p:sp>
+      <p:sp>
+        <p:nvSpPr>
+          <p:cNvPr id="34" name="Shape 32"/>
+          <p:cNvSpPr/>
+          <p:nvPr/>
+        </p:nvSpPr>
+        <p:spPr>
+          <a:xfrm>
+            <a:off x="6821424" y="3456432"/>
+            <a:ext cx="438912" cy="438912"/>
+          </a:xfrm>
+          <a:prstGeom prst="ellipse">
+            <a:avLst/>
+          </a:prstGeom>
+          <a:solidFill>
+            <a:srgbClr val="8B5CF6"/>
+          </a:solidFill>
+          <a:ln/>
+        </p:spPr>
+      </p:sp>
+      <p:sp>
+        <p:nvSpPr>
+          <p:cNvPr id="35" name="Text 33"/>
+          <p:cNvSpPr/>
+          <p:nvPr/>
+        </p:nvSpPr>
+        <p:spPr>
+          <a:xfrm>
+            <a:off x="6821424" y="3593592"/>
+            <a:ext cx="438912" cy="109728"/>
+          </a:xfrm>
+          <a:prstGeom prst="rect">
+            <a:avLst/>
+          </a:prstGeom>
+          <a:noFill/>
+          <a:ln/>
+        </p:spPr>
+        <p:txBody>
+          <a:bodyPr wrap="square" lIns="0" tIns="0" rIns="0" bIns="0" rtlCol="0" anchor="ctr"/>
+          <a:lstStyle/>
+          <a:p>
+            <a:pPr algn="ctr" indent="0" marL="0">
+              <a:buNone/>
+            </a:pPr>
+            <a:r>
+              <a:rPr lang="en-US" sz="900" b="1" dirty="0">
+                <a:solidFill>
+                  <a:srgbClr val="11162B"/>
+                </a:solidFill>
+                <a:latin typeface="Aptos" pitchFamily="34" charset="0"/>
+                <a:ea typeface="Aptos" pitchFamily="34" charset="-122"/>
+                <a:cs typeface="Aptos" pitchFamily="34" charset="-120"/>
+              </a:rPr>
+              <a:t>2</a:t>
+            </a:r>
+            <a:endParaRPr lang="en-US" sz="900" dirty="0"/>
+          </a:p>
+        </p:txBody>
+      </p:sp>
+      <p:sp>
+        <p:nvSpPr>
+          <p:cNvPr id="36" name="Text 34"/>
+          <p:cNvSpPr/>
+          <p:nvPr/>
+        </p:nvSpPr>
+        <p:spPr>
+          <a:xfrm>
+            <a:off x="7498080" y="3291840"/>
+            <a:ext cx="3886200" cy="749808"/>
+          </a:xfrm>
+          <a:prstGeom prst="rect">
+            <a:avLst/>
+          </a:prstGeom>
+          <a:noFill/>
+          <a:ln/>
+        </p:spPr>
+        <p:txBody>
+          <a:bodyPr wrap="square" lIns="0" tIns="0" rIns="0" bIns="0" rtlCol="0" anchor="ctr">
+            <a:normAutofit/>
+          </a:bodyPr>
+          <a:lstStyle/>
+          <a:p>
+            <a:pPr indent="0" marL="0">
+              <a:buNone/>
+            </a:pPr>
+            <a:r>
+              <a:rPr lang="en-US" sz="1450" dirty="0">
+                <a:solidFill>
+                  <a:srgbClr val="151B31"/>
+                </a:solidFill>
+                <a:latin typeface="Aptos" pitchFamily="34" charset="0"/>
+                <a:ea typeface="Aptos" pitchFamily="34" charset="-122"/>
+                <a:cs typeface="Aptos" pitchFamily="34" charset="-120"/>
+              </a:rPr>
+              <a:t>Use the Foundry SDK and OpenTelemetry tracing packages</a:t>
+            </a:r>
+            <a:endParaRPr lang="en-US" sz="1450" dirty="0"/>
+          </a:p>
+        </p:txBody>
+      </p:sp>
+      <p:sp>
+        <p:nvSpPr>
+          <p:cNvPr id="37" name="Shape 35"/>
+          <p:cNvSpPr/>
+          <p:nvPr/>
+        </p:nvSpPr>
+        <p:spPr>
+          <a:xfrm>
+            <a:off x="6821424" y="4572000"/>
+            <a:ext cx="438912" cy="438912"/>
+          </a:xfrm>
+          <a:prstGeom prst="ellipse">
+            <a:avLst/>
+          </a:prstGeom>
+          <a:solidFill>
+            <a:srgbClr val="8B5CF6"/>
+          </a:solidFill>
+          <a:ln/>
+        </p:spPr>
+      </p:sp>
+      <p:sp>
+        <p:nvSpPr>
+          <p:cNvPr id="38" name="Text 36"/>
+          <p:cNvSpPr/>
+          <p:nvPr/>
+        </p:nvSpPr>
+        <p:spPr>
+          <a:xfrm>
+            <a:off x="6821424" y="4709160"/>
+            <a:ext cx="438912" cy="109728"/>
+          </a:xfrm>
+          <a:prstGeom prst="rect">
+            <a:avLst/>
+          </a:prstGeom>
+          <a:noFill/>
+          <a:ln/>
+        </p:spPr>
+        <p:txBody>
+          <a:bodyPr wrap="square" lIns="0" tIns="0" rIns="0" bIns="0" rtlCol="0" anchor="ctr"/>
+          <a:lstStyle/>
+          <a:p>
+            <a:pPr algn="ctr" indent="0" marL="0">
+              <a:buNone/>
+            </a:pPr>
+            <a:r>
+              <a:rPr lang="en-US" sz="900" b="1" dirty="0">
+                <a:solidFill>
+                  <a:srgbClr val="11162B"/>
+                </a:solidFill>
+                <a:latin typeface="Aptos" pitchFamily="34" charset="0"/>
+                <a:ea typeface="Aptos" pitchFamily="34" charset="-122"/>
+                <a:cs typeface="Aptos" pitchFamily="34" charset="-120"/>
+              </a:rPr>
+              <a:t>3</a:t>
+            </a:r>
+            <a:endParaRPr lang="en-US" sz="900" dirty="0"/>
+          </a:p>
+        </p:txBody>
+      </p:sp>
+      <p:sp>
+        <p:nvSpPr>
+          <p:cNvPr id="39" name="Text 37"/>
+          <p:cNvSpPr/>
+          <p:nvPr/>
+        </p:nvSpPr>
+        <p:spPr>
+          <a:xfrm>
+            <a:off x="7498080" y="4407408"/>
+            <a:ext cx="3886200" cy="749808"/>
+          </a:xfrm>
+          <a:prstGeom prst="rect">
+            <a:avLst/>
+          </a:prstGeom>
+          <a:noFill/>
+          <a:ln/>
+        </p:spPr>
+        <p:txBody>
+          <a:bodyPr wrap="square" lIns="0" tIns="0" rIns="0" bIns="0" rtlCol="0" anchor="ctr">
+            <a:normAutofit/>
+          </a:bodyPr>
+          <a:lstStyle/>
+          <a:p>
+            <a:pPr indent="0" marL="0">
+              <a:buNone/>
+            </a:pPr>
+            <a:r>
+              <a:rPr lang="en-US" sz="1450" dirty="0">
+                <a:solidFill>
+                  <a:srgbClr val="151B31"/>
+                </a:solidFill>
+                <a:latin typeface="Aptos" pitchFamily="34" charset="0"/>
+                <a:ea typeface="Aptos" pitchFamily="34" charset="-122"/>
+                <a:cs typeface="Aptos" pitchFamily="34" charset="-120"/>
+              </a:rPr>
+              <a:t>Export the trace to Azure Monitor or the console</a:t>
+            </a:r>
+            <a:endParaRPr lang="en-US" sz="1450" dirty="0"/>
+          </a:p>
+        </p:txBody>
+      </p:sp>
+      <p:sp>
+        <p:nvSpPr>
+          <p:cNvPr id="40" name="Text 38"/>
+          <p:cNvSpPr/>
+          <p:nvPr/>
+        </p:nvSpPr>
+        <p:spPr>
+          <a:xfrm>
+            <a:off x="658368" y="6318504"/>
+            <a:ext cx="10881360" cy="182880"/>
+          </a:xfrm>
+          <a:prstGeom prst="rect">
+            <a:avLst/>
+          </a:prstGeom>
+          <a:noFill/>
+          <a:ln/>
+        </p:spPr>
+        <p:txBody>
+          <a:bodyPr wrap="square" lIns="0" tIns="0" rIns="0" bIns="0" rtlCol="0" anchor="ctr">
+            <a:normAutofit/>
+          </a:bodyPr>
+          <a:lstStyle/>
+          <a:p>
+            <a:pPr indent="0" marL="0">
+              <a:buNone/>
+            </a:pPr>
+            <a:r>
+              <a:rPr lang="en-US" sz="940" dirty="0">
+                <a:solidFill>
+                  <a:srgbClr val="526276"/>
+                </a:solidFill>
+                <a:latin typeface="Aptos" pitchFamily="34" charset="0"/>
+                <a:ea typeface="Aptos" pitchFamily="34" charset="-122"/>
+                <a:cs typeface="Aptos" pitchFamily="34" charset="-120"/>
+              </a:rPr>
+              <a:t>REFERENCE  learn.microsoft.com/azure/foundry/observability/how-to/trace-agent-setup</a:t>
+            </a:r>
+            <a:endParaRPr lang="en-US" sz="940" dirty="0"/>
+          </a:p>
+        </p:txBody>
+      </p:sp>
+      <p:sp>
+        <p:nvSpPr>
+          <p:cNvPr id="41" name="Shape 39"/>
           <p:cNvSpPr/>
           <p:nvPr/>
         </p:nvSpPr>
@@ -2655,7 +5530,7 @@
                 <a:ea typeface="Aptos" pitchFamily="34" charset="-122"/>
                 <a:cs typeface="Aptos" pitchFamily="34" charset="-120"/>
               </a:rPr>
-              <a:t>02</a:t>
+              <a:t>03</a:t>
             </a:r>
             <a:endParaRPr lang="en-US" sz="850" dirty="0"/>
           </a:p>
@@ -3649,7 +6524,7 @@
                 <a:ea typeface="Aptos Display" pitchFamily="34" charset="-122"/>
                 <a:cs typeface="Aptos Display" pitchFamily="34" charset="-120"/>
               </a:rPr>
-              <a:t>Name the evidence inside one request</a:t>
+              <a:t>Evidence from one agent run</a:t>
             </a:r>
             <a:endParaRPr lang="en-US" sz="3100" dirty="0"/>
           </a:p>
@@ -3925,7 +6800,7 @@
                 <a:ea typeface="Aptos" pitchFamily="34" charset="-122"/>
                 <a:cs typeface="Aptos" pitchFamily="34" charset="-120"/>
               </a:rPr>
-              <a:t>03</a:t>
+              <a:t>04</a:t>
             </a:r>
             <a:endParaRPr lang="en-US" sz="850" dirty="0"/>
           </a:p>
@@ -4509,7 +7384,7 @@
                 <a:ea typeface="Consolas" pitchFamily="34" charset="-122"/>
                 <a:cs typeface="Consolas" pitchFamily="34" charset="-120"/>
               </a:rPr>
-              <a:t>TRACE  /  request 9f2a</a:t>
+              <a:t>AUTOMATIC SPANS  /  SAME TRACE</a:t>
             </a:r>
             <a:endParaRPr lang="en-US" sz="1100" dirty="0"/>
           </a:p>
@@ -4595,7 +7470,7 @@
                 <a:ea typeface="Consolas" pitchFamily="34" charset="-122"/>
                 <a:cs typeface="Consolas" pitchFamily="34" charset="-120"/>
               </a:rPr>
-              <a:t>workflow.run  2.8 s</a:t>
+              <a:t>invoke_agent WeatherAgent</a:t>
             </a:r>
             <a:endParaRPr lang="en-US" sz="1050" dirty="0"/>
           </a:p>
@@ -4658,7 +7533,7 @@
                 <a:ea typeface="Consolas" pitchFamily="34" charset="-122"/>
                 <a:cs typeface="Consolas" pitchFamily="34" charset="-120"/>
               </a:rPr>
-              <a:t>retrieval  1.4 s</a:t>
+              <a:t>chat &lt;model&gt;</a:t>
             </a:r>
             <a:endParaRPr lang="en-US" sz="1050" dirty="0"/>
           </a:p>
@@ -4721,7 +7596,7 @@
                 <a:ea typeface="Consolas" pitchFamily="34" charset="-122"/>
                 <a:cs typeface="Consolas" pitchFamily="34" charset="-120"/>
               </a:rPr>
-              <a:t>critic  0.6 s</a:t>
+              <a:t>execute_tool get_weather</a:t>
             </a:r>
             <a:endParaRPr lang="en-US" sz="1050" dirty="0"/>
           </a:p>
@@ -4784,7 +7659,7 @@
                 <a:ea typeface="Consolas" pitchFamily="34" charset="-122"/>
                 <a:cs typeface="Consolas" pitchFamily="34" charset="-120"/>
               </a:rPr>
-              <a:t>model=gpt</a:t>
+              <a:t>agent=weather-agent</a:t>
             </a:r>
             <a:endParaRPr lang="en-US" sz="1020" dirty="0"/>
           </a:p>
@@ -4910,7 +7785,7 @@
                 <a:ea typeface="Consolas" pitchFamily="34" charset="-122"/>
                 <a:cs typeface="Consolas" pitchFamily="34" charset="-120"/>
               </a:rPr>
-              <a:t>route=deliver</a:t>
+              <a:t>tool=get_weather</a:t>
             </a:r>
             <a:endParaRPr lang="en-US" sz="1020" dirty="0"/>
           </a:p>
@@ -4971,7 +7846,7 @@
                 <a:ea typeface="Aptos Display" pitchFamily="34" charset="-122"/>
                 <a:cs typeface="Aptos Display" pitchFamily="34" charset="-120"/>
               </a:rPr>
-              <a:t>Console event list</a:t>
+              <a:t>Custom span</a:t>
             </a:r>
             <a:endParaRPr lang="en-US" sz="1650" dirty="0"/>
           </a:p>
@@ -5012,7 +7887,7 @@
                 <a:ea typeface="Aptos" pitchFamily="34" charset="-122"/>
                 <a:cs typeface="Aptos" pitchFamily="34" charset="-120"/>
               </a:rPr>
-              <a:t>Application output; useful, but not automatically a cloud trace</a:t>
+              <a:t>Application code adds business or scenario context around recorded work</a:t>
             </a:r>
             <a:endParaRPr lang="en-US" sz="1340" dirty="0"/>
           </a:p>
@@ -5053,7 +7928,7 @@
                 <a:ea typeface="Aptos" pitchFamily="34" charset="-122"/>
                 <a:cs typeface="Aptos" pitchFamily="34" charset="-120"/>
               </a:rPr>
-              <a:t>REFERENCE  learn.microsoft.com/azure/foundry/observability/concepts/trace-agent-concept</a:t>
+              <a:t>REFERENCE  learn.microsoft.com/azure/foundry/observability/concepts/trace-agent-concept  ·  +1 more in notes</a:t>
             </a:r>
             <a:endParaRPr lang="en-US" sz="940" dirty="0"/>
           </a:p>
@@ -5209,7 +8084,7 @@
                 <a:ea typeface="Aptos Display" pitchFamily="34" charset="-122"/>
                 <a:cs typeface="Aptos Display" pitchFamily="34" charset="-120"/>
               </a:rPr>
-              <a:t>From instrumentation to a trace backend</a:t>
+              <a:t>How telemetry reaches Foundry and Application Insights</a:t>
             </a:r>
             <a:endParaRPr lang="en-US" sz="3100" dirty="0"/>
           </a:p>
@@ -5485,7 +8360,7 @@
                 <a:ea typeface="Aptos" pitchFamily="34" charset="-122"/>
                 <a:cs typeface="Aptos" pitchFamily="34" charset="-120"/>
               </a:rPr>
-              <a:t>04</a:t>
+              <a:t>05</a:t>
             </a:r>
             <a:endParaRPr lang="en-US" sz="850" dirty="0"/>
           </a:p>
@@ -5857,7 +8732,7 @@
                 <a:ea typeface="Aptos" pitchFamily="34" charset="-122"/>
                 <a:cs typeface="Aptos" pitchFamily="34" charset="-120"/>
               </a:rPr>
-              <a:t>Shared names aid interpretation; names alone do not propagate trace context</a:t>
+              <a:t>Shared names aid interpretation but names alone do not propagate trace context</a:t>
             </a:r>
             <a:endParaRPr lang="en-US" sz="1420" dirty="0"/>
           </a:p>
@@ -6343,7 +9218,7 @@
                 <a:ea typeface="Aptos Display" pitchFamily="34" charset="-122"/>
                 <a:cs typeface="Aptos Display" pitchFamily="34" charset="-120"/>
               </a:rPr>
-              <a:t>Label maturity</a:t>
+              <a:t>Note</a:t>
             </a:r>
             <a:endParaRPr lang="en-US" sz="1800" dirty="0"/>
           </a:p>
@@ -6582,7 +9457,7 @@
                 <a:ea typeface="Aptos Display" pitchFamily="34" charset="-122"/>
                 <a:cs typeface="Aptos Display" pitchFamily="34" charset="-120"/>
               </a:rPr>
-              <a:t>Workflow causality is not always nesting</a:t>
+              <a:t>Workflow traces are graphs, not parent/child trees</a:t>
             </a:r>
             <a:endParaRPr lang="en-US" sz="3100" dirty="0"/>
           </a:p>
@@ -6858,7 +9733,7 @@
                 <a:ea typeface="Aptos" pitchFamily="34" charset="-122"/>
                 <a:cs typeface="Aptos" pitchFamily="34" charset="-120"/>
               </a:rPr>
-              <a:t>05</a:t>
+              <a:t>07</a:t>
             </a:r>
             <a:endParaRPr lang="en-US" sz="850" dirty="0"/>
           </a:p>
@@ -7690,7 +10565,7 @@
                 <a:ea typeface="Aptos" pitchFamily="34" charset="-122"/>
                 <a:cs typeface="Aptos" pitchFamily="34" charset="-120"/>
               </a:rPr>
-              <a:t>First streamed output is not workflow completion; do not expect a span per token</a:t>
+              <a:t>First streamed output is not workflow completion</a:t>
             </a:r>
             <a:endParaRPr lang="en-US" sz="1360" dirty="0"/>
           </a:p>
@@ -7797,8 +10672,8 @@
         </p:nvSpPr>
         <p:spPr>
           <a:xfrm>
-            <a:off x="182880" y="4407408"/>
-            <a:ext cx="1572768" cy="1572768"/>
+            <a:off x="274320" y="4306320"/>
+            <a:ext cx="1417320" cy="1417320"/>
           </a:xfrm>
           <a:prstGeom prst="ellipse">
             <a:avLst/>
@@ -7876,8 +10751,8 @@
         </p:nvSpPr>
         <p:spPr>
           <a:xfrm>
-            <a:off x="713232" y="1143000"/>
-            <a:ext cx="6199632" cy="914400"/>
+            <a:off x="713232" y="1088136"/>
+            <a:ext cx="6199632" cy="1051560"/>
           </a:xfrm>
           <a:prstGeom prst="rect">
             <a:avLst/>
@@ -7895,7 +10770,7 @@
               <a:buNone/>
             </a:pPr>
             <a:r>
-              <a:rPr lang="en-US" sz="3900" b="1" dirty="0">
+              <a:rPr lang="en-US" sz="3500" b="1" dirty="0">
                 <a:solidFill>
                   <a:srgbClr val="FFFFFF"/>
                 </a:solidFill>
@@ -7903,9 +10778,21 @@
                 <a:ea typeface="Aptos Display" pitchFamily="34" charset="-122"/>
                 <a:cs typeface="Aptos Display" pitchFamily="34" charset="-120"/>
               </a:rPr>
-              <a:t>Follow one request</a:t>
-            </a:r>
-            <a:endParaRPr lang="en-US" sz="3900" dirty="0"/>
+              <a:t>Compare client-side and</a:t>
+            </a:r>
+            <a:br/>
+            <a:r>
+              <a:rPr lang="en-US" sz="3500" b="1" dirty="0">
+                <a:solidFill>
+                  <a:srgbClr val="FFFFFF"/>
+                </a:solidFill>
+                <a:latin typeface="Aptos Display" pitchFamily="34" charset="0"/>
+                <a:ea typeface="Aptos Display" pitchFamily="34" charset="-122"/>
+                <a:cs typeface="Aptos Display" pitchFamily="34" charset="-120"/>
+              </a:rPr>
+              <a:t>server-side traces</a:t>
+            </a:r>
+            <a:endParaRPr lang="en-US" sz="3500" dirty="0"/>
           </a:p>
         </p:txBody>
       </p:sp>
@@ -7936,7 +10823,7 @@
               <a:buNone/>
             </a:pPr>
             <a:r>
-              <a:rPr lang="en-US" sz="1540" dirty="0">
+              <a:rPr lang="en-US" sz="1540" b="1" dirty="0">
                 <a:solidFill>
                   <a:srgbClr val="E5EBF0"/>
                 </a:solidFill>
@@ -7944,7 +10831,7 @@
                 <a:ea typeface="Aptos" pitchFamily="34" charset="-122"/>
                 <a:cs typeface="Aptos" pitchFamily="34" charset="-120"/>
               </a:rPr>
-              <a:t>Follow the same synthetic request through console events and an authentic exported trace.</a:t>
+              <a:t>STEP 1 — CLIENT-SIDE</a:t>
             </a:r>
             <a:endParaRPr lang="en-US" sz="1540" dirty="0"/>
           </a:p>
@@ -7961,7 +10848,7 @@
                 <a:ea typeface="Aptos" pitchFamily="34" charset="-122"/>
                 <a:cs typeface="Aptos" pitchFamily="34" charset="-120"/>
               </a:rPr>
-              <a:t>Find the retrieval operation, the recorded revision-or-stop decision, and the longest span.</a:t>
+              <a:t>Run WeatherAgent; inspect its custom parent and automatic spans.</a:t>
             </a:r>
             <a:endParaRPr lang="en-US" sz="1540" dirty="0"/>
           </a:p>
@@ -7970,7 +10857,7 @@
               <a:buNone/>
             </a:pPr>
             <a:r>
-              <a:rPr lang="en-US" sz="1540" dirty="0">
+              <a:rPr lang="en-US" sz="1540" b="1" dirty="0">
                 <a:solidFill>
                   <a:srgbClr val="E5EBF0"/>
                 </a:solidFill>
@@ -7978,7 +10865,24 @@
                 <a:ea typeface="Aptos" pitchFamily="34" charset="-122"/>
                 <a:cs typeface="Aptos" pitchFamily="34" charset="-120"/>
               </a:rPr>
-              <a:t>Then separate the latency finding from the reviewed or evaluated answer-quality evidence.</a:t>
+              <a:t>STEP 2 — SERVER-SIDE</a:t>
+            </a:r>
+            <a:endParaRPr lang="en-US" sz="1540" dirty="0"/>
+          </a:p>
+          <a:p>
+            <a:pPr indent="0" marL="0">
+              <a:buNone/>
+            </a:pPr>
+            <a:r>
+              <a:rPr lang="en-US" sz="1540" dirty="0">
+                <a:solidFill>
+                  <a:srgbClr val="E5EBF0"/>
+                </a:solidFill>
+                <a:latin typeface="Aptos" pitchFamily="34" charset="0"/>
+                <a:ea typeface="Aptos" pitchFamily="34" charset="-122"/>
+                <a:cs typeface="Aptos" pitchFamily="34" charset="-120"/>
+              </a:rPr>
+              <a:t>Run docs-assistant in Foundry; inspect its trace in Agents &gt; Traces.</a:t>
             </a:r>
             <a:endParaRPr lang="en-US" sz="1540" dirty="0"/>
           </a:p>
@@ -8061,7 +10965,7 @@
                 <a:ea typeface="Aptos" pitchFamily="34" charset="-122"/>
                 <a:cs typeface="Aptos" pitchFamily="34" charset="-120"/>
               </a:rPr>
-              <a:t>~6 min</a:t>
+              <a:t>~8 min</a:t>
             </a:r>
             <a:endParaRPr lang="en-US" sz="950" dirty="0"/>
           </a:p>
@@ -8200,7 +11104,7 @@
                 <a:ea typeface="Aptos" pitchFamily="34" charset="-122"/>
                 <a:cs typeface="Aptos" pitchFamily="34" charset="-120"/>
               </a:rPr>
-              <a:t>Longest recorded span</a:t>
+              <a:t>Client trace: custom + automatic spans</a:t>
             </a:r>
             <a:endParaRPr lang="en-US" sz="1480" dirty="0"/>
           </a:p>
@@ -8300,7 +11204,7 @@
                 <a:ea typeface="Aptos" pitchFamily="34" charset="-122"/>
                 <a:cs typeface="Aptos" pitchFamily="34" charset="-120"/>
               </a:rPr>
-              <a:t>Links versus nesting</a:t>
+              <a:t>Server trace: Foundry-managed coverage</a:t>
             </a:r>
             <a:endParaRPr lang="en-US" sz="1480" dirty="0"/>
           </a:p>
@@ -8400,7 +11304,7 @@
                 <a:ea typeface="Aptos" pitchFamily="34" charset="-122"/>
                 <a:cs typeface="Aptos" pitchFamily="34" charset="-120"/>
               </a:rPr>
-              <a:t>Quality needs separate evidence</a:t>
+              <a:t>Separate trace IDs, duration, and status</a:t>
             </a:r>
             <a:endParaRPr lang="en-US" sz="1480" dirty="0"/>
           </a:p>
@@ -8463,7 +11367,7 @@
                 <a:ea typeface="Consolas" pitchFamily="34" charset="-122"/>
                 <a:cs typeface="Consolas" pitchFamily="34" charset="-120"/>
               </a:rPr>
-              <a:t>demos/day5/module-1-demo-1-follow-one-request.md</a:t>
+              <a:t>RUNBOOK  Module 1 trace demo guide</a:t>
             </a:r>
             <a:endParaRPr lang="en-US" sz="1100" dirty="0"/>
           </a:p>
@@ -8504,7 +11408,7 @@
                 <a:ea typeface="Aptos" pitchFamily="34" charset="-122"/>
                 <a:cs typeface="Aptos" pitchFamily="34" charset="-120"/>
               </a:rPr>
-              <a:t>REFERENCE  learn.microsoft.com/azure/foundry/observability/concepts/trace-agent-concept  ·  +2 more in notes</a:t>
+              <a:t>REFERENCE  github.com/microsoft/agent-framework  ·  +3 more in notes</a:t>
             </a:r>
             <a:endParaRPr lang="en-US" sz="940" dirty="0"/>
           </a:p>
@@ -8660,7 +11564,7 @@
                 <a:ea typeface="Aptos Display" pitchFamily="34" charset="-122"/>
                 <a:cs typeface="Aptos Display" pitchFamily="34" charset="-120"/>
               </a:rPr>
-              <a:t>Telemetry is another data store</a:t>
+              <a:t>Treat trace telemetry as governed data</a:t>
             </a:r>
             <a:endParaRPr lang="en-US" sz="3100" dirty="0"/>
           </a:p>
@@ -8936,7 +11840,7 @@
                 <a:ea typeface="Aptos" pitchFamily="34" charset="-122"/>
                 <a:cs typeface="Aptos" pitchFamily="34" charset="-120"/>
               </a:rPr>
-              <a:t>07</a:t>
+              <a:t>09</a:t>
             </a:r>
             <a:endParaRPr lang="en-US" sz="850" dirty="0"/>
           </a:p>
@@ -10126,7 +13030,7 @@
                 <a:ea typeface="Aptos Display" pitchFamily="34" charset="-122"/>
                 <a:cs typeface="Aptos Display" pitchFamily="34" charset="-120"/>
               </a:rPr>
-              <a:t>Checkpoint: slow is not the same as wrong</a:t>
+              <a:t>Separate latency, failure, and answer quality</a:t>
             </a:r>
             <a:endParaRPr lang="en-US" sz="3100" dirty="0"/>
           </a:p>
@@ -10402,7 +13306,7 @@
                 <a:ea typeface="Aptos" pitchFamily="34" charset="-122"/>
                 <a:cs typeface="Aptos" pitchFamily="34" charset="-120"/>
               </a:rPr>
-              <a:t>08</a:t>
+              <a:t>10</a:t>
             </a:r>
             <a:endParaRPr lang="en-US" sz="850" dirty="0"/>
           </a:p>
@@ -10598,7 +13502,7 @@
                 <a:ea typeface="Aptos" pitchFamily="34" charset="-122"/>
                 <a:cs typeface="Aptos" pitchFamily="34" charset="-120"/>
               </a:rPr>
-              <a:t>Compare span durations and relationships; the supplied trace points to retrieval</a:t>
+              <a:t>Compare actual agent, model, tool, and custom-span durations</a:t>
             </a:r>
             <a:endParaRPr lang="en-US" sz="1420" dirty="0"/>
           </a:p>
@@ -11599,7 +14503,7 @@
                 <a:ea typeface="Aptos" pitchFamily="34" charset="-122"/>
                 <a:cs typeface="Aptos" pitchFamily="34" charset="-120"/>
               </a:rPr>
-              <a:t>09</a:t>
+              <a:t>11</a:t>
             </a:r>
             <a:endParaRPr lang="en-US" sz="850" dirty="0"/>
           </a:p>
@@ -12185,7 +15089,7 @@
                 <a:ea typeface="Aptos" pitchFamily="34" charset="-122"/>
                 <a:cs typeface="Aptos" pitchFamily="34" charset="-120"/>
               </a:rPr>
-              <a:t>A trace contains spans, and spans carry attributes; console events are not automatically cloud traces.</a:t>
+              <a:t>A trace contains spans, and spans carry attributes that describe recorded operations.</a:t>
             </a:r>
             <a:endParaRPr lang="en-US" sz="1530" dirty="0"/>
           </a:p>
@@ -12312,7 +15216,7 @@
                 <a:ea typeface="Aptos" pitchFamily="34" charset="-122"/>
                 <a:cs typeface="Aptos" pitchFamily="34" charset="-120"/>
               </a:rPr>
-              <a:t>OpenTelemetry links express causal workflow handoffs without inventing parent/child nesting.</a:t>
+              <a:t>Agent Framework emits automatic spans; custom spans add application-defined context.</a:t>
             </a:r>
             <a:endParaRPr lang="en-US" sz="1530" dirty="0"/>
           </a:p>
@@ -12439,7 +15343,7 @@
                 <a:ea typeface="Aptos" pitchFamily="34" charset="-122"/>
                 <a:cs typeface="Aptos" pitchFamily="34" charset="-120"/>
               </a:rPr>
-              <a:t>Instrumentation, context propagation, and export are separate responsibilities.</a:t>
+              <a:t>Context propagation correlates boundaries; links express causal handoffs without inventing nesting.</a:t>
             </a:r>
             <a:endParaRPr lang="en-US" sz="1530" dirty="0"/>
           </a:p>
@@ -12607,7 +15511,7 @@
                 <a:ea typeface="Aptos" pitchFamily="34" charset="-122"/>
                 <a:cs typeface="Aptos" pitchFamily="34" charset="-120"/>
               </a:rPr>
-              <a:t>REFERENCE  learn.microsoft.com/azure/foundry/concepts/observability  ·  +2 more in notes</a:t>
+              <a:t>REFERENCE  learn.microsoft.com/azure/foundry/concepts/observability  ·  +3 more in notes</a:t>
             </a:r>
             <a:endParaRPr lang="en-US" sz="940" dirty="0"/>
           </a:p>

</xml_diff>